<commit_message>
Talk: finalize the ~22-min script + deck around the memory-systems headline
- codebase-tour.md: rewritten arc (loop -> context -> demo1 -> safe-split -> policies
  seam + harness.compare -> THE memory-systems bake-off as the headline -> war stories
  -> payoff). Repoints to harness/policies/; adds the 5th war story (making the OSS
  adapters run). Both live demos pre-flighted offline and pass.
- founsi-talk.pptx (17 slides): adds "you are not alone" (the OSS-systems map) and
  "and I measured them" (recency 0.45 vs LangChain 0.35; nv-embedqa 0.50 vs MiniLM
  0.35; Mem0 trails raw chunks at higher per-add cost), plus the adapter war story.

Co-Authored-By: Claude Opus 4.8 <noreply@anthropic.com>
</commit_message>
<xml_diff>
--- a/presentation/founsi-talk.pptx
+++ b/presentation/founsi-talk.pptx
@@ -19,9 +19,12 @@
     <p:sldId id="267" r:id="rId13"/>
     <p:sldId id="268" r:id="rId14"/>
     <p:sldId id="269" r:id="rId15"/>
+    <p:sldId id="270" r:id="rId16"/>
+    <p:sldId id="271" r:id="rId17"/>
+    <p:sldId id="272" r:id="rId18"/>
   </p:sldIdLst>
   <p:notesMasterIdLst>
-    <p:notesMasterId r:id="rId16"/>
+    <p:notesMasterId r:id="rId19"/>
   </p:notesMasterIdLst>
   <p:sldSz cx="9144000" cy="5143500"/>
   <p:notesSz cx="5143500" cy="9144000"/>
@@ -979,6 +982,270 @@
             <a:fld id="{F7021451-1387-4CA6-816F-3879F97B5CBC}" type="slidenum">
               <a:rPr lang="en-US"/>
               <a:t>14</a:t>
+            </a:fld>
+            <a:endParaRPr lang="en-US"/>
+          </a:p>
+        </p:txBody>
+      </p:sp>
+    </p:spTree>
+    <p:extLst>
+      <p:ext uri="{BB962C8B-B14F-4D97-AF65-F5344CB8AC3E}">
+        <p14:creationId xmlns:p14="http://schemas.microsoft.com/office/powerpoint/2010/main" val="1024086991"/>
+      </p:ext>
+    </p:extLst>
+  </p:cSld>
+  <p:clrMapOvr>
+    <a:masterClrMapping/>
+  </p:clrMapOvr>
+</p:notes>
+</file>
+
+<file path=ppt/notesSlides/notesSlide15.xml><?xml version="1.0" encoding="utf-8"?>
+<p:notes xmlns:a="http://schemas.openxmlformats.org/drawingml/2006/main" xmlns:r="http://schemas.openxmlformats.org/officeDocument/2006/relationships" xmlns:p="http://schemas.openxmlformats.org/presentationml/2006/main">
+  <p:cSld>
+    <p:spTree>
+      <p:nvGrpSpPr>
+        <p:cNvPr id="1" name=""/>
+        <p:cNvGrpSpPr/>
+        <p:nvPr/>
+      </p:nvGrpSpPr>
+      <p:grpSpPr>
+        <a:xfrm>
+          <a:off x="0" y="0"/>
+          <a:ext cx="0" cy="0"/>
+          <a:chOff x="0" y="0"/>
+          <a:chExt cx="0" cy="0"/>
+        </a:xfrm>
+      </p:grpSpPr>
+      <p:sp>
+        <p:nvSpPr>
+          <p:cNvPr id="2" name="Slide Image Placeholder 1"/>
+          <p:cNvSpPr>
+            <a:spLocks noGrp="1" noRot="1" noChangeAspect="1"/>
+          </p:cNvSpPr>
+          <p:nvPr>
+            <p:ph type="sldImg"/>
+          </p:nvPr>
+        </p:nvSpPr>
+        <p:spPr/>
+      </p:sp>
+      <p:sp>
+        <p:nvSpPr>
+          <p:cNvPr id="3" name="Notes Placeholder 2"/>
+          <p:cNvSpPr>
+            <a:spLocks noGrp="1"/>
+          </p:cNvSpPr>
+          <p:nvPr>
+            <p:ph type="body" idx="1"/>
+          </p:nvPr>
+        </p:nvSpPr>
+        <p:spPr/>
+        <p:txBody>
+          <a:bodyPr/>
+          <a:lstStyle/>
+          <a:p>
+            <a:r>
+              <a:rPr lang="en-US" dirty="0"/>
+              <a:t/>
+            </a:r>
+            <a:endParaRPr lang="en-US" dirty="0"/>
+          </a:p>
+        </p:txBody>
+      </p:sp>
+      <p:sp>
+        <p:nvSpPr>
+          <p:cNvPr id="4" name="Slide Number Placeholder 3"/>
+          <p:cNvSpPr>
+            <a:spLocks noGrp="1"/>
+          </p:cNvSpPr>
+          <p:nvPr>
+            <p:ph type="sldNum" sz="quarter" idx="10"/>
+          </p:nvPr>
+        </p:nvSpPr>
+        <p:spPr/>
+        <p:txBody>
+          <a:bodyPr/>
+          <a:lstStyle/>
+          <a:p>
+            <a:fld id="{F7021451-1387-4CA6-816F-3879F97B5CBC}" type="slidenum">
+              <a:rPr lang="en-US"/>
+              <a:t>15</a:t>
+            </a:fld>
+            <a:endParaRPr lang="en-US"/>
+          </a:p>
+        </p:txBody>
+      </p:sp>
+    </p:spTree>
+    <p:extLst>
+      <p:ext uri="{BB962C8B-B14F-4D97-AF65-F5344CB8AC3E}">
+        <p14:creationId xmlns:p14="http://schemas.microsoft.com/office/powerpoint/2010/main" val="1024086991"/>
+      </p:ext>
+    </p:extLst>
+  </p:cSld>
+  <p:clrMapOvr>
+    <a:masterClrMapping/>
+  </p:clrMapOvr>
+</p:notes>
+</file>
+
+<file path=ppt/notesSlides/notesSlide16.xml><?xml version="1.0" encoding="utf-8"?>
+<p:notes xmlns:a="http://schemas.openxmlformats.org/drawingml/2006/main" xmlns:r="http://schemas.openxmlformats.org/officeDocument/2006/relationships" xmlns:p="http://schemas.openxmlformats.org/presentationml/2006/main">
+  <p:cSld>
+    <p:spTree>
+      <p:nvGrpSpPr>
+        <p:cNvPr id="1" name=""/>
+        <p:cNvGrpSpPr/>
+        <p:nvPr/>
+      </p:nvGrpSpPr>
+      <p:grpSpPr>
+        <a:xfrm>
+          <a:off x="0" y="0"/>
+          <a:ext cx="0" cy="0"/>
+          <a:chOff x="0" y="0"/>
+          <a:chExt cx="0" cy="0"/>
+        </a:xfrm>
+      </p:grpSpPr>
+      <p:sp>
+        <p:nvSpPr>
+          <p:cNvPr id="2" name="Slide Image Placeholder 1"/>
+          <p:cNvSpPr>
+            <a:spLocks noGrp="1" noRot="1" noChangeAspect="1"/>
+          </p:cNvSpPr>
+          <p:nvPr>
+            <p:ph type="sldImg"/>
+          </p:nvPr>
+        </p:nvSpPr>
+        <p:spPr/>
+      </p:sp>
+      <p:sp>
+        <p:nvSpPr>
+          <p:cNvPr id="3" name="Notes Placeholder 2"/>
+          <p:cNvSpPr>
+            <a:spLocks noGrp="1"/>
+          </p:cNvSpPr>
+          <p:nvPr>
+            <p:ph type="body" idx="1"/>
+          </p:nvPr>
+        </p:nvSpPr>
+        <p:spPr/>
+        <p:txBody>
+          <a:bodyPr/>
+          <a:lstStyle/>
+          <a:p>
+            <a:r>
+              <a:rPr lang="en-US" dirty="0"/>
+              <a:t/>
+            </a:r>
+            <a:endParaRPr lang="en-US" dirty="0"/>
+          </a:p>
+        </p:txBody>
+      </p:sp>
+      <p:sp>
+        <p:nvSpPr>
+          <p:cNvPr id="4" name="Slide Number Placeholder 3"/>
+          <p:cNvSpPr>
+            <a:spLocks noGrp="1"/>
+          </p:cNvSpPr>
+          <p:nvPr>
+            <p:ph type="sldNum" sz="quarter" idx="10"/>
+          </p:nvPr>
+        </p:nvSpPr>
+        <p:spPr/>
+        <p:txBody>
+          <a:bodyPr/>
+          <a:lstStyle/>
+          <a:p>
+            <a:fld id="{F7021451-1387-4CA6-816F-3879F97B5CBC}" type="slidenum">
+              <a:rPr lang="en-US"/>
+              <a:t>16</a:t>
+            </a:fld>
+            <a:endParaRPr lang="en-US"/>
+          </a:p>
+        </p:txBody>
+      </p:sp>
+    </p:spTree>
+    <p:extLst>
+      <p:ext uri="{BB962C8B-B14F-4D97-AF65-F5344CB8AC3E}">
+        <p14:creationId xmlns:p14="http://schemas.microsoft.com/office/powerpoint/2010/main" val="1024086991"/>
+      </p:ext>
+    </p:extLst>
+  </p:cSld>
+  <p:clrMapOvr>
+    <a:masterClrMapping/>
+  </p:clrMapOvr>
+</p:notes>
+</file>
+
+<file path=ppt/notesSlides/notesSlide17.xml><?xml version="1.0" encoding="utf-8"?>
+<p:notes xmlns:a="http://schemas.openxmlformats.org/drawingml/2006/main" xmlns:r="http://schemas.openxmlformats.org/officeDocument/2006/relationships" xmlns:p="http://schemas.openxmlformats.org/presentationml/2006/main">
+  <p:cSld>
+    <p:spTree>
+      <p:nvGrpSpPr>
+        <p:cNvPr id="1" name=""/>
+        <p:cNvGrpSpPr/>
+        <p:nvPr/>
+      </p:nvGrpSpPr>
+      <p:grpSpPr>
+        <a:xfrm>
+          <a:off x="0" y="0"/>
+          <a:ext cx="0" cy="0"/>
+          <a:chOff x="0" y="0"/>
+          <a:chExt cx="0" cy="0"/>
+        </a:xfrm>
+      </p:grpSpPr>
+      <p:sp>
+        <p:nvSpPr>
+          <p:cNvPr id="2" name="Slide Image Placeholder 1"/>
+          <p:cNvSpPr>
+            <a:spLocks noGrp="1" noRot="1" noChangeAspect="1"/>
+          </p:cNvSpPr>
+          <p:nvPr>
+            <p:ph type="sldImg"/>
+          </p:nvPr>
+        </p:nvSpPr>
+        <p:spPr/>
+      </p:sp>
+      <p:sp>
+        <p:nvSpPr>
+          <p:cNvPr id="3" name="Notes Placeholder 2"/>
+          <p:cNvSpPr>
+            <a:spLocks noGrp="1"/>
+          </p:cNvSpPr>
+          <p:nvPr>
+            <p:ph type="body" idx="1"/>
+          </p:nvPr>
+        </p:nvSpPr>
+        <p:spPr/>
+        <p:txBody>
+          <a:bodyPr/>
+          <a:lstStyle/>
+          <a:p>
+            <a:r>
+              <a:rPr lang="en-US" dirty="0"/>
+              <a:t/>
+            </a:r>
+            <a:endParaRPr lang="en-US" dirty="0"/>
+          </a:p>
+        </p:txBody>
+      </p:sp>
+      <p:sp>
+        <p:nvSpPr>
+          <p:cNvPr id="4" name="Slide Number Placeholder 3"/>
+          <p:cNvSpPr>
+            <a:spLocks noGrp="1"/>
+          </p:cNvSpPr>
+          <p:nvPr>
+            <p:ph type="sldNum" sz="quarter" idx="10"/>
+          </p:nvPr>
+        </p:nvSpPr>
+        <p:spPr/>
+        <p:txBody>
+          <a:bodyPr/>
+          <a:lstStyle/>
+          <a:p>
+            <a:fld id="{F7021451-1387-4CA6-816F-3879F97B5CBC}" type="slidenum">
+              <a:rPr lang="en-US"/>
+              <a:t>17</a:t>
             </a:fld>
             <a:endParaRPr lang="en-US"/>
           </a:p>
@@ -2330,7 +2597,7 @@
                 <a:ea typeface="Syne" pitchFamily="34" charset="-122"/>
                 <a:cs typeface="Syne" pitchFamily="34" charset="-120"/>
               </a:rPr>
-              <a:t>AND SO WHAT?</a:t>
+              <a:t>WAR STORY</a:t>
             </a:r>
             <a:endParaRPr lang="en-US" sz="1100" dirty="0"/>
           </a:p>
@@ -2344,17 +2611,17 @@
         </p:nvSpPr>
         <p:spPr>
           <a:xfrm>
-            <a:off x="548640" y="640080"/>
-            <a:ext cx="8046720" cy="822960"/>
-          </a:xfrm>
-          <a:prstGeom prst="rect">
-            <a:avLst/>
-          </a:prstGeom>
-          <a:noFill/>
-          <a:ln/>
-        </p:spPr>
-        <p:txBody>
-          <a:bodyPr wrap="square" lIns="0" tIns="0" rIns="0" bIns="0" rtlCol="0" anchor="t"/>
+            <a:off x="548640" y="658368"/>
+            <a:ext cx="8046720" cy="457200"/>
+          </a:xfrm>
+          <a:prstGeom prst="rect">
+            <a:avLst/>
+          </a:prstGeom>
+          <a:noFill/>
+          <a:ln/>
+        </p:spPr>
+        <p:txBody>
+          <a:bodyPr wrap="square" lIns="0" tIns="0" rIns="0" bIns="0" rtlCol="0" anchor="ctr"/>
           <a:lstStyle/>
           <a:p>
             <a:pPr indent="0" marL="0">
@@ -2369,15 +2636,166 @@
                 <a:ea typeface="Syne" pitchFamily="34" charset="-122"/>
                 <a:cs typeface="Syne" pitchFamily="34" charset="-120"/>
               </a:rPr>
-              <a:t>The best way to forget depends on the task.</a:t>
+              <a:t>The reasoning model that wouldn't shut up</a:t>
             </a:r>
             <a:endParaRPr lang="en-US" sz="2400" dirty="0"/>
+          </a:p>
+        </p:txBody>
+      </p:sp>
+      <p:sp>
+        <p:nvSpPr>
+          <p:cNvPr id="4" name="Text 2"/>
+          <p:cNvSpPr/>
+          <p:nvPr/>
+        </p:nvSpPr>
+        <p:spPr>
+          <a:xfrm>
+            <a:off x="548640" y="1463040"/>
+            <a:ext cx="8046720" cy="914400"/>
+          </a:xfrm>
+          <a:prstGeom prst="rect">
+            <a:avLst/>
+          </a:prstGeom>
+          <a:noFill/>
+          <a:ln/>
+        </p:spPr>
+        <p:txBody>
+          <a:bodyPr wrap="square" lIns="0" tIns="0" rIns="0" bIns="0" rtlCol="0" anchor="ctr"/>
+          <a:lstStyle/>
+          <a:p>
+            <a:pPr indent="0" marL="0">
+              <a:buNone/>
+            </a:pPr>
+            <a:r>
+              <a:rPr lang="en-US" sz="4000" b="1" dirty="0">
+                <a:solidFill>
+                  <a:srgbClr val="9378FF"/>
+                </a:solidFill>
+                <a:latin typeface="Syne" pitchFamily="34" charset="0"/>
+                <a:ea typeface="Syne" pitchFamily="34" charset="-122"/>
+                <a:cs typeface="Syne" pitchFamily="34" charset="-120"/>
+              </a:rPr>
+              <a:t>2k–20k token 'summaries'</a:t>
+            </a:r>
+            <a:endParaRPr lang="en-US" sz="4000" dirty="0"/>
+          </a:p>
+        </p:txBody>
+      </p:sp>
+      <p:sp>
+        <p:nvSpPr>
+          <p:cNvPr id="5" name="Text 3"/>
+          <p:cNvSpPr/>
+          <p:nvPr/>
+        </p:nvSpPr>
+        <p:spPr>
+          <a:xfrm>
+            <a:off x="548640" y="2606040"/>
+            <a:ext cx="8046720" cy="1097280"/>
+          </a:xfrm>
+          <a:prstGeom prst="rect">
+            <a:avLst/>
+          </a:prstGeom>
+          <a:noFill/>
+          <a:ln/>
+        </p:spPr>
+        <p:txBody>
+          <a:bodyPr wrap="square" lIns="0" tIns="0" rIns="0" bIns="0" rtlCol="0" anchor="ctr"/>
+          <a:lstStyle/>
+          <a:p>
+            <a:pPr indent="0" marL="0">
+              <a:buNone/>
+            </a:pPr>
+            <a:r>
+              <a:rPr lang="en-US" sz="1600" dirty="0">
+                <a:solidFill>
+                  <a:srgbClr val="2E2C32"/>
+                </a:solidFill>
+                <a:latin typeface="Manrope" pitchFamily="34" charset="0"/>
+                <a:ea typeface="Manrope" pitchFamily="34" charset="-122"/>
+                <a:cs typeface="Manrope" pitchFamily="34" charset="-120"/>
+              </a:rPr>
+              <a:t>Asked to compress, it rambled; turning thinking off corrupted it. Fix: a split summarizer (fast model compacts, reasoning model answers).</a:t>
+            </a:r>
+            <a:endParaRPr lang="en-US" sz="1600" dirty="0"/>
+          </a:p>
+        </p:txBody>
+      </p:sp>
+      <p:sp>
+        <p:nvSpPr>
+          <p:cNvPr id="6" name="Shape 4"/>
+          <p:cNvSpPr/>
+          <p:nvPr/>
+        </p:nvSpPr>
+        <p:spPr>
+          <a:xfrm>
+            <a:off x="548640" y="3886200"/>
+            <a:ext cx="91440" cy="457200"/>
+          </a:xfrm>
+          <a:prstGeom prst="rect">
+            <a:avLst/>
+          </a:prstGeom>
+          <a:solidFill>
+            <a:srgbClr val="9378FF"/>
+          </a:solidFill>
+          <a:ln/>
+        </p:spPr>
+      </p:sp>
+      <p:sp>
+        <p:nvSpPr>
+          <p:cNvPr id="7" name="Text 5"/>
+          <p:cNvSpPr/>
+          <p:nvPr/>
+        </p:nvSpPr>
+        <p:spPr>
+          <a:xfrm>
+            <a:off x="768096" y="3886200"/>
+            <a:ext cx="7863840" cy="457200"/>
+          </a:xfrm>
+          <a:prstGeom prst="rect">
+            <a:avLst/>
+          </a:prstGeom>
+          <a:noFill/>
+          <a:ln/>
+        </p:spPr>
+        <p:txBody>
+          <a:bodyPr wrap="square" lIns="0" tIns="0" rIns="0" bIns="0" rtlCol="0" anchor="ctr"/>
+          <a:lstStyle/>
+          <a:p>
+            <a:pPr indent="0" marL="0">
+              <a:buNone/>
+            </a:pPr>
+            <a:r>
+              <a:rPr lang="en-US" sz="1400" b="1" dirty="0">
+                <a:solidFill>
+                  <a:srgbClr val="7B5EF0"/>
+                </a:solidFill>
+                <a:latin typeface="Manrope" pitchFamily="34" charset="0"/>
+                <a:ea typeface="Manrope" pitchFamily="34" charset="-122"/>
+                <a:cs typeface="Manrope" pitchFamily="34" charset="-120"/>
+              </a:rPr>
+              <a:t>Lesson  </a:t>
+            </a:r>
+            <a:pPr indent="0" marL="0">
+              <a:buNone/>
+            </a:pPr>
+            <a:r>
+              <a:rPr lang="en-US" sz="1400" dirty="0">
+                <a:solidFill>
+                  <a:srgbClr val="655E74"/>
+                </a:solidFill>
+                <a:latin typeface="Manrope" pitchFamily="34" charset="0"/>
+                <a:ea typeface="Manrope" pitchFamily="34" charset="-122"/>
+                <a:cs typeface="Manrope" pitchFamily="34" charset="-120"/>
+              </a:rPr>
+              <a:t>Reasoning models are bad compactors.</a:t>
+            </a:r>
+            <a:endParaRPr lang="en-US" sz="1400" dirty="0"/>
           </a:p>
         </p:txBody>
       </p:sp>
       <p:pic>
         <p:nvPicPr>
-          <p:cNvPr id="4" name="Image 0" descr="preencoded.png">    </p:cNvPr>
+          <p:cNvPr id="8" name="Image 0" descr="preencoded.png">    </p:cNvPr>
           <p:cNvPicPr>
             <a:picLocks noChangeAspect="1"/>
           </p:cNvPicPr>
@@ -2401,7 +2819,7 @@
       </p:pic>
       <p:sp>
         <p:nvSpPr>
-          <p:cNvPr id="5" name="Text 2"/>
+          <p:cNvPr id="9" name="Text 6"/>
           <p:cNvSpPr/>
           <p:nvPr/>
         </p:nvSpPr>
@@ -2454,7 +2872,7 @@
       </p:sp>
       <p:sp>
         <p:nvSpPr>
-          <p:cNvPr id="6" name="Text 3"/>
+          <p:cNvPr id="10" name="Text 7"/>
           <p:cNvSpPr/>
           <p:nvPr/>
         </p:nvSpPr>
@@ -2488,136 +2906,6 @@
               <a:t>10</a:t>
             </a:r>
             <a:endParaRPr lang="en-US" sz="900" dirty="0"/>
-          </a:p>
-        </p:txBody>
-      </p:sp>
-      <p:pic>
-        <p:nvPicPr>
-          <p:cNvPr id="7" name="Image 1" descr="/Users/kanishk/Desktop/agent-harness/presentation/figures/EXP-004_transfer_v1.png">    </p:cNvPr>
-          <p:cNvPicPr>
-            <a:picLocks noChangeAspect="1"/>
-          </p:cNvPicPr>
-          <p:nvPr/>
-        </p:nvPicPr>
-        <p:blipFill>
-          <a:blip r:embed="rId2"/>
-          <a:stretch>
-            <a:fillRect/>
-          </a:stretch>
-        </p:blipFill>
-        <p:spPr>
-          <a:xfrm>
-            <a:off x="640080" y="1371600"/>
-            <a:ext cx="4846320" cy="3291840"/>
-          </a:xfrm>
-          <a:prstGeom prst="rect">
-            <a:avLst/>
-          </a:prstGeom>
-        </p:spPr>
-      </p:pic>
-      <p:sp>
-        <p:nvSpPr>
-          <p:cNvPr id="8" name="Text 4"/>
-          <p:cNvSpPr/>
-          <p:nvPr/>
-        </p:nvSpPr>
-        <p:spPr>
-          <a:xfrm>
-            <a:off x="5669280" y="1508760"/>
-            <a:ext cx="3017520" cy="2743200"/>
-          </a:xfrm>
-          <a:prstGeom prst="rect">
-            <a:avLst/>
-          </a:prstGeom>
-          <a:noFill/>
-          <a:ln/>
-        </p:spPr>
-        <p:txBody>
-          <a:bodyPr wrap="square" rtlCol="0" anchor="ctr"/>
-          <a:lstStyle/>
-          <a:p>
-            <a:pPr marL="203200" indent="-203200">
-              <a:spcAft>
-                <a:spcPts val="900"/>
-              </a:spcAft>
-              <a:buSzPct val="100000"/>
-              <a:buChar char="•"/>
-            </a:pPr>
-            <a:r>
-              <a:rPr lang="en-US" sz="1250" dirty="0">
-                <a:solidFill>
-                  <a:srgbClr val="2E2C32"/>
-                </a:solidFill>
-                <a:latin typeface="Manrope" pitchFamily="34" charset="0"/>
-                <a:ea typeface="Manrope" pitchFamily="34" charset="-122"/>
-                <a:cs typeface="Manrope" pitchFamily="34" charset="-120"/>
-              </a:rPr>
-              <a:t>Same 7 policies, two task types, three model sizes.</a:t>
-            </a:r>
-            <a:endParaRPr lang="en-US" sz="1250" dirty="0"/>
-          </a:p>
-          <a:p>
-            <a:pPr marL="203200" indent="-203200">
-              <a:spcAft>
-                <a:spcPts val="900"/>
-              </a:spcAft>
-              <a:buSzPct val="100000"/>
-              <a:buChar char="•"/>
-            </a:pPr>
-            <a:r>
-              <a:rPr lang="en-US" sz="1250" dirty="0">
-                <a:solidFill>
-                  <a:srgbClr val="2E2C32"/>
-                </a:solidFill>
-                <a:latin typeface="Manrope" pitchFamily="34" charset="0"/>
-                <a:ea typeface="Manrope" pitchFamily="34" charset="-122"/>
-                <a:cs typeface="Manrope" pitchFamily="34" charset="-120"/>
-              </a:rPr>
-              <a:t>The ranking INVERTS: summarize for factual, keep-the-raw for memory.</a:t>
-            </a:r>
-            <a:endParaRPr lang="en-US" sz="1250" dirty="0"/>
-          </a:p>
-          <a:p>
-            <a:pPr marL="203200" indent="-203200">
-              <a:spcAft>
-                <a:spcPts val="900"/>
-              </a:spcAft>
-              <a:buSzPct val="100000"/>
-              <a:buChar char="•"/>
-            </a:pPr>
-            <a:r>
-              <a:rPr lang="en-US" sz="1050" dirty="0">
-                <a:solidFill>
-                  <a:srgbClr val="655E74"/>
-                </a:solidFill>
-                <a:latin typeface="Manrope" pitchFamily="34" charset="0"/>
-                <a:ea typeface="Manrope" pitchFamily="34" charset="-122"/>
-                <a:cs typeface="Manrope" pitchFamily="34" charset="-120"/>
-              </a:rPr>
-              <a:t>The one policy never in the loser group keeps BOTH a summary and the raw.</a:t>
-            </a:r>
-            <a:endParaRPr lang="en-US" sz="1250" dirty="0"/>
-          </a:p>
-          <a:p>
-            <a:pPr marL="203200" indent="-203200">
-              <a:spcAft>
-                <a:spcPts val="900"/>
-              </a:spcAft>
-              <a:buSzPct val="100000"/>
-              <a:buChar char="•"/>
-            </a:pPr>
-            <a:r>
-              <a:rPr lang="en-US" sz="1250" dirty="0">
-                <a:solidFill>
-                  <a:srgbClr val="2E2C32"/>
-                </a:solidFill>
-                <a:latin typeface="Manrope" pitchFamily="34" charset="0"/>
-                <a:ea typeface="Manrope" pitchFamily="34" charset="-122"/>
-                <a:cs typeface="Manrope" pitchFamily="34" charset="-120"/>
-              </a:rPr>
-              <a:t>Error bars are bootstrap 95% CIs (FRAMES is still noisy at n=30).</a:t>
-            </a:r>
-            <a:endParaRPr lang="en-US" sz="1250" dirty="0"/>
           </a:p>
         </p:txBody>
       </p:sp>
@@ -2686,7 +2974,7 @@
                 <a:ea typeface="Syne" pitchFamily="34" charset="-122"/>
                 <a:cs typeface="Syne" pitchFamily="34" charset="-120"/>
               </a:rPr>
-              <a:t>AND SO WHAT?</a:t>
+              <a:t>WAR STORY</a:t>
             </a:r>
             <a:endParaRPr lang="en-US" sz="1100" dirty="0"/>
           </a:p>
@@ -2700,17 +2988,17 @@
         </p:nvSpPr>
         <p:spPr>
           <a:xfrm>
-            <a:off x="548640" y="640080"/>
-            <a:ext cx="8046720" cy="822960"/>
-          </a:xfrm>
-          <a:prstGeom prst="rect">
-            <a:avLst/>
-          </a:prstGeom>
-          <a:noFill/>
-          <a:ln/>
-        </p:spPr>
-        <p:txBody>
-          <a:bodyPr wrap="square" lIns="0" tIns="0" rIns="0" bIns="0" rtlCol="0" anchor="t"/>
+            <a:off x="548640" y="658368"/>
+            <a:ext cx="8046720" cy="457200"/>
+          </a:xfrm>
+          <a:prstGeom prst="rect">
+            <a:avLst/>
+          </a:prstGeom>
+          <a:noFill/>
+          <a:ln/>
+        </p:spPr>
+        <p:txBody>
+          <a:bodyPr wrap="square" lIns="0" tIns="0" rIns="0" bIns="0" rtlCol="0" anchor="ctr"/>
           <a:lstStyle/>
           <a:p>
             <a:pPr indent="0" marL="0">
@@ -2725,15 +3013,166 @@
                 <a:ea typeface="Syne" pitchFamily="34" charset="-122"/>
                 <a:cs typeface="Syne" pitchFamily="34" charset="-120"/>
               </a:rPr>
-              <a:t>The policy that ships in most agents is weak.</a:t>
+              <a:t>The confound I caught the day before</a:t>
             </a:r>
             <a:endParaRPr lang="en-US" sz="2400" dirty="0"/>
+          </a:p>
+        </p:txBody>
+      </p:sp>
+      <p:sp>
+        <p:nvSpPr>
+          <p:cNvPr id="4" name="Text 2"/>
+          <p:cNvSpPr/>
+          <p:nvPr/>
+        </p:nvSpPr>
+        <p:spPr>
+          <a:xfrm>
+            <a:off x="548640" y="1463040"/>
+            <a:ext cx="8046720" cy="914400"/>
+          </a:xfrm>
+          <a:prstGeom prst="rect">
+            <a:avLst/>
+          </a:prstGeom>
+          <a:noFill/>
+          <a:ln/>
+        </p:spPr>
+        <p:txBody>
+          <a:bodyPr wrap="square" lIns="0" tIns="0" rIns="0" bIns="0" rtlCol="0" anchor="ctr"/>
+          <a:lstStyle/>
+          <a:p>
+            <a:pPr indent="0" marL="0">
+              <a:buNone/>
+            </a:pPr>
+            <a:r>
+              <a:rPr lang="en-US" sz="4000" b="1" dirty="0">
+                <a:solidFill>
+                  <a:srgbClr val="9378FF"/>
+                </a:solidFill>
+                <a:latin typeface="Syne" pitchFamily="34" charset="0"/>
+                <a:ea typeface="Syne" pitchFamily="34" charset="-122"/>
+                <a:cs typeface="Syne" pitchFamily="34" charset="-120"/>
+              </a:rPr>
+              <a:t>0.67  →  0.53</a:t>
+            </a:r>
+            <a:endParaRPr lang="en-US" sz="4000" dirty="0"/>
+          </a:p>
+        </p:txBody>
+      </p:sp>
+      <p:sp>
+        <p:nvSpPr>
+          <p:cNvPr id="5" name="Text 3"/>
+          <p:cNvSpPr/>
+          <p:nvPr/>
+        </p:nvSpPr>
+        <p:spPr>
+          <a:xfrm>
+            <a:off x="548640" y="2606040"/>
+            <a:ext cx="8046720" cy="1097280"/>
+          </a:xfrm>
+          <a:prstGeom prst="rect">
+            <a:avLst/>
+          </a:prstGeom>
+          <a:noFill/>
+          <a:ln/>
+        </p:spPr>
+        <p:txBody>
+          <a:bodyPr wrap="square" lIns="0" tIns="0" rIns="0" bIns="0" rtlCol="0" anchor="ctr"/>
+          <a:lstStyle/>
+          <a:p>
+            <a:pPr indent="0" marL="0">
+              <a:buNone/>
+            </a:pPr>
+            <a:r>
+              <a:rPr lang="en-US" sz="1600" dirty="0">
+                <a:solidFill>
+                  <a:srgbClr val="2E2C32"/>
+                </a:solidFill>
+                <a:latin typeface="Manrope" pitchFamily="34" charset="0"/>
+                <a:ea typeface="Manrope" pitchFamily="34" charset="-122"/>
+                <a:cs typeface="Manrope" pitchFamily="34" charset="-120"/>
+              </a:rPr>
+              <a:t>My 70B headline win shrank once I held the summarizer constant. The win was partly the summarizer, not the answer model.</a:t>
+            </a:r>
+            <a:endParaRPr lang="en-US" sz="1600" dirty="0"/>
+          </a:p>
+        </p:txBody>
+      </p:sp>
+      <p:sp>
+        <p:nvSpPr>
+          <p:cNvPr id="6" name="Shape 4"/>
+          <p:cNvSpPr/>
+          <p:nvPr/>
+        </p:nvSpPr>
+        <p:spPr>
+          <a:xfrm>
+            <a:off x="548640" y="3886200"/>
+            <a:ext cx="91440" cy="457200"/>
+          </a:xfrm>
+          <a:prstGeom prst="rect">
+            <a:avLst/>
+          </a:prstGeom>
+          <a:solidFill>
+            <a:srgbClr val="9378FF"/>
+          </a:solidFill>
+          <a:ln/>
+        </p:spPr>
+      </p:sp>
+      <p:sp>
+        <p:nvSpPr>
+          <p:cNvPr id="7" name="Text 5"/>
+          <p:cNvSpPr/>
+          <p:nvPr/>
+        </p:nvSpPr>
+        <p:spPr>
+          <a:xfrm>
+            <a:off x="768096" y="3886200"/>
+            <a:ext cx="7863840" cy="457200"/>
+          </a:xfrm>
+          <a:prstGeom prst="rect">
+            <a:avLst/>
+          </a:prstGeom>
+          <a:noFill/>
+          <a:ln/>
+        </p:spPr>
+        <p:txBody>
+          <a:bodyPr wrap="square" lIns="0" tIns="0" rIns="0" bIns="0" rtlCol="0" anchor="ctr"/>
+          <a:lstStyle/>
+          <a:p>
+            <a:pPr indent="0" marL="0">
+              <a:buNone/>
+            </a:pPr>
+            <a:r>
+              <a:rPr lang="en-US" sz="1400" b="1" dirty="0">
+                <a:solidFill>
+                  <a:srgbClr val="7B5EF0"/>
+                </a:solidFill>
+                <a:latin typeface="Manrope" pitchFamily="34" charset="0"/>
+                <a:ea typeface="Manrope" pitchFamily="34" charset="-122"/>
+                <a:cs typeface="Manrope" pitchFamily="34" charset="-120"/>
+              </a:rPr>
+              <a:t>Lesson  </a:t>
+            </a:r>
+            <a:pPr indent="0" marL="0">
+              <a:buNone/>
+            </a:pPr>
+            <a:r>
+              <a:rPr lang="en-US" sz="1400" dirty="0">
+                <a:solidFill>
+                  <a:srgbClr val="655E74"/>
+                </a:solidFill>
+                <a:latin typeface="Manrope" pitchFamily="34" charset="0"/>
+                <a:ea typeface="Manrope" pitchFamily="34" charset="-122"/>
+                <a:cs typeface="Manrope" pitchFamily="34" charset="-120"/>
+              </a:rPr>
+              <a:t>Isolate your variable, even when it costs the headline.</a:t>
+            </a:r>
+            <a:endParaRPr lang="en-US" sz="1400" dirty="0"/>
           </a:p>
         </p:txBody>
       </p:sp>
       <p:pic>
         <p:nvPicPr>
-          <p:cNvPr id="4" name="Image 0" descr="preencoded.png">    </p:cNvPr>
+          <p:cNvPr id="8" name="Image 0" descr="preencoded.png">    </p:cNvPr>
           <p:cNvPicPr>
             <a:picLocks noChangeAspect="1"/>
           </p:cNvPicPr>
@@ -2757,7 +3196,7 @@
       </p:pic>
       <p:sp>
         <p:nvSpPr>
-          <p:cNvPr id="5" name="Text 2"/>
+          <p:cNvPr id="9" name="Text 6"/>
           <p:cNvSpPr/>
           <p:nvPr/>
         </p:nvSpPr>
@@ -2810,7 +3249,7 @@
       </p:sp>
       <p:sp>
         <p:nvSpPr>
-          <p:cNvPr id="6" name="Text 3"/>
+          <p:cNvPr id="10" name="Text 7"/>
           <p:cNvSpPr/>
           <p:nvPr/>
         </p:nvSpPr>
@@ -2844,183 +3283,6 @@
               <a:t>11</a:t>
             </a:r>
             <a:endParaRPr lang="en-US" sz="900" dirty="0"/>
-          </a:p>
-        </p:txBody>
-      </p:sp>
-      <p:sp>
-        <p:nvSpPr>
-          <p:cNvPr id="7" name="Shape 4"/>
-          <p:cNvSpPr/>
-          <p:nvPr/>
-        </p:nvSpPr>
-        <p:spPr>
-          <a:xfrm>
-            <a:off x="640080" y="1645920"/>
-            <a:ext cx="7863840" cy="868680"/>
-          </a:xfrm>
-          <a:prstGeom prst="rect">
-            <a:avLst/>
-          </a:prstGeom>
-          <a:solidFill>
-            <a:srgbClr val="F4F2F8"/>
-          </a:solidFill>
-          <a:ln w="12700">
-            <a:solidFill>
-              <a:srgbClr val="D4C9FF"/>
-            </a:solidFill>
-            <a:prstDash val="solid"/>
-          </a:ln>
-        </p:spPr>
-      </p:sp>
-      <p:sp>
-        <p:nvSpPr>
-          <p:cNvPr id="8" name="Text 5"/>
-          <p:cNvSpPr/>
-          <p:nvPr/>
-        </p:nvSpPr>
-        <p:spPr>
-          <a:xfrm>
-            <a:off x="822960" y="1645920"/>
-            <a:ext cx="7498080" cy="868680"/>
-          </a:xfrm>
-          <a:prstGeom prst="rect">
-            <a:avLst/>
-          </a:prstGeom>
-          <a:noFill/>
-          <a:ln/>
-        </p:spPr>
-        <p:txBody>
-          <a:bodyPr wrap="square" lIns="0" tIns="0" rIns="0" bIns="0" rtlCol="0" anchor="ctr"/>
-          <a:lstStyle/>
-          <a:p>
-            <a:pPr indent="0" marL="0">
-              <a:buNone/>
-            </a:pPr>
-            <a:r>
-              <a:rPr lang="en-US" sz="1800" b="1" dirty="0">
-                <a:solidFill>
-                  <a:srgbClr val="2E2C32"/>
-                </a:solidFill>
-                <a:latin typeface="Manrope" pitchFamily="34" charset="0"/>
-                <a:ea typeface="Manrope" pitchFamily="34" charset="-122"/>
-                <a:cs typeface="Manrope" pitchFamily="34" charset="-120"/>
-              </a:rPr>
-              <a:t>recency summary  </a:t>
-            </a:r>
-            <a:pPr indent="0" marL="0">
-              <a:buNone/>
-            </a:pPr>
-            <a:r>
-              <a:rPr lang="en-US" sz="1600" dirty="0">
-                <a:solidFill>
-                  <a:srgbClr val="655E74"/>
-                </a:solidFill>
-                <a:latin typeface="Manrope" pitchFamily="34" charset="0"/>
-                <a:ea typeface="Manrope" pitchFamily="34" charset="-122"/>
-                <a:cs typeface="Manrope" pitchFamily="34" charset="-120"/>
-              </a:rPr>
-              <a:t>= truncation's accuracy,  </a:t>
-            </a:r>
-            <a:pPr indent="0" marL="0">
-              <a:buNone/>
-            </a:pPr>
-            <a:r>
-              <a:rPr lang="en-US" sz="1800" b="1" dirty="0">
-                <a:solidFill>
-                  <a:srgbClr val="A32D2D"/>
-                </a:solidFill>
-                <a:latin typeface="Manrope" pitchFamily="34" charset="0"/>
-                <a:ea typeface="Manrope" pitchFamily="34" charset="-122"/>
-                <a:cs typeface="Manrope" pitchFamily="34" charset="-120"/>
-              </a:rPr>
-              <a:t>7× the cost.</a:t>
-            </a:r>
-            <a:endParaRPr lang="en-US" sz="1800" dirty="0"/>
-          </a:p>
-        </p:txBody>
-      </p:sp>
-      <p:sp>
-        <p:nvSpPr>
-          <p:cNvPr id="9" name="Text 6"/>
-          <p:cNvSpPr/>
-          <p:nvPr/>
-        </p:nvSpPr>
-        <p:spPr>
-          <a:xfrm>
-            <a:off x="548640" y="2788920"/>
-            <a:ext cx="8046720" cy="2743200"/>
-          </a:xfrm>
-          <a:prstGeom prst="rect">
-            <a:avLst/>
-          </a:prstGeom>
-          <a:noFill/>
-          <a:ln/>
-        </p:spPr>
-        <p:txBody>
-          <a:bodyPr wrap="square" rtlCol="0" anchor="ctr"/>
-          <a:lstStyle/>
-          <a:p>
-            <a:pPr marL="203200" indent="-203200">
-              <a:spcAft>
-                <a:spcPts val="900"/>
-              </a:spcAft>
-              <a:buSzPct val="100000"/>
-              <a:buChar char="•"/>
-            </a:pPr>
-            <a:r>
-              <a:rPr lang="en-US" sz="1400" dirty="0">
-                <a:solidFill>
-                  <a:srgbClr val="2E2C32"/>
-                </a:solidFill>
-                <a:latin typeface="Manrope" pitchFamily="34" charset="0"/>
-                <a:ea typeface="Manrope" pitchFamily="34" charset="-122"/>
-                <a:cs typeface="Manrope" pitchFamily="34" charset="-120"/>
-              </a:rPr>
-              <a:t>Summarizing the stale middle bought nothing over just dropping it, under pressure.</a:t>
-            </a:r>
-            <a:endParaRPr lang="en-US" sz="1400" dirty="0"/>
-          </a:p>
-          <a:p>
-            <a:pPr marL="203200" indent="-203200">
-              <a:spcAft>
-                <a:spcPts val="900"/>
-              </a:spcAft>
-              <a:buSzPct val="100000"/>
-              <a:buChar char="•"/>
-            </a:pPr>
-            <a:r>
-              <a:rPr lang="en-US" sz="1400" dirty="0">
-                <a:solidFill>
-                  <a:srgbClr val="2E2C32"/>
-                </a:solidFill>
-                <a:latin typeface="Manrope" pitchFamily="34" charset="0"/>
-                <a:ea typeface="Manrope" pitchFamily="34" charset="-122"/>
-                <a:cs typeface="Manrope" pitchFamily="34" charset="-120"/>
-              </a:rPr>
-              <a:t>Sub-agent isolation: same accuracy as keeping turns, 5× the cost. A trap on this task.</a:t>
-            </a:r>
-            <a:endParaRPr lang="en-US" sz="1400" dirty="0"/>
-          </a:p>
-          <a:p>
-            <a:pPr marL="203200" indent="-203200">
-              <a:spcAft>
-                <a:spcPts val="900"/>
-              </a:spcAft>
-              <a:buSzPct val="100000"/>
-              <a:buChar char="•"/>
-            </a:pPr>
-            <a:r>
-              <a:rPr lang="en-US" sz="1200" dirty="0">
-                <a:solidFill>
-                  <a:srgbClr val="655E74"/>
-                </a:solidFill>
-                <a:latin typeface="Manrope" pitchFamily="34" charset="0"/>
-                <a:ea typeface="Manrope" pitchFamily="34" charset="-122"/>
-                <a:cs typeface="Manrope" pitchFamily="34" charset="-120"/>
-              </a:rPr>
-              <a:t>Both are cost-normalized negatives that anyone running agents can use today.</a:t>
-            </a:r>
-            <a:endParaRPr lang="en-US" sz="1400" dirty="0"/>
           </a:p>
         </p:txBody>
       </p:sp>
@@ -3038,7 +3300,7 @@
     <p:bg>
       <p:bgPr>
         <a:solidFill>
-          <a:srgbClr val="2E2C32"/>
+          <a:srgbClr val="FAFAFE"/>
         </a:solidFill>
       </p:bgPr>
     </p:bg>
@@ -3064,107 +3326,230 @@
         </p:nvSpPr>
         <p:spPr>
           <a:xfrm>
-            <a:off x="731520" y="1920240"/>
-            <a:ext cx="7680960" cy="914400"/>
-          </a:xfrm>
-          <a:prstGeom prst="rect">
-            <a:avLst/>
-          </a:prstGeom>
-          <a:noFill/>
-          <a:ln/>
-        </p:spPr>
-        <p:txBody>
-          <a:bodyPr wrap="square" lIns="0" tIns="0" rIns="0" bIns="0" rtlCol="0" anchor="ctr"/>
-          <a:lstStyle/>
-          <a:p>
-            <a:pPr algn="ctr" indent="0" marL="0">
-              <a:buNone/>
-            </a:pPr>
-            <a:r>
-              <a:rPr lang="en-US" sz="3800" b="1" dirty="0">
-                <a:solidFill>
-                  <a:srgbClr val="FFFFFF"/>
+            <a:off x="548640" y="365760"/>
+            <a:ext cx="8046720" cy="274320"/>
+          </a:xfrm>
+          <a:prstGeom prst="rect">
+            <a:avLst/>
+          </a:prstGeom>
+          <a:noFill/>
+          <a:ln/>
+        </p:spPr>
+        <p:txBody>
+          <a:bodyPr wrap="square" lIns="0" tIns="0" rIns="0" bIns="0" rtlCol="0" anchor="ctr"/>
+          <a:lstStyle/>
+          <a:p>
+            <a:pPr indent="0" marL="0">
+              <a:buNone/>
+            </a:pPr>
+            <a:r>
+              <a:rPr lang="en-US" sz="1100" b="1" spc="300" kern="0" dirty="0">
+                <a:solidFill>
+                  <a:srgbClr val="9378FF"/>
                 </a:solidFill>
                 <a:latin typeface="Syne" pitchFamily="34" charset="0"/>
                 <a:ea typeface="Syne" pitchFamily="34" charset="-122"/>
                 <a:cs typeface="Syne" pitchFamily="34" charset="-120"/>
               </a:rPr>
-              <a:t>Keep the raw </a:t>
-            </a:r>
-            <a:pPr algn="ctr" indent="0" marL="0">
-              <a:buNone/>
-            </a:pPr>
-            <a:r>
-              <a:rPr lang="en-US" sz="3800" b="1" i="1" dirty="0">
-                <a:solidFill>
-                  <a:srgbClr val="9378FF"/>
+              <a:t>WAR STORY</a:t>
+            </a:r>
+            <a:endParaRPr lang="en-US" sz="1100" dirty="0"/>
+          </a:p>
+        </p:txBody>
+      </p:sp>
+      <p:sp>
+        <p:nvSpPr>
+          <p:cNvPr id="3" name="Text 1"/>
+          <p:cNvSpPr/>
+          <p:nvPr/>
+        </p:nvSpPr>
+        <p:spPr>
+          <a:xfrm>
+            <a:off x="548640" y="658368"/>
+            <a:ext cx="8046720" cy="457200"/>
+          </a:xfrm>
+          <a:prstGeom prst="rect">
+            <a:avLst/>
+          </a:prstGeom>
+          <a:noFill/>
+          <a:ln/>
+        </p:spPr>
+        <p:txBody>
+          <a:bodyPr wrap="square" lIns="0" tIns="0" rIns="0" bIns="0" rtlCol="0" anchor="ctr"/>
+          <a:lstStyle/>
+          <a:p>
+            <a:pPr indent="0" marL="0">
+              <a:buNone/>
+            </a:pPr>
+            <a:r>
+              <a:rPr lang="en-US" sz="2400" b="1" dirty="0">
+                <a:solidFill>
+                  <a:srgbClr val="2E2C32"/>
                 </a:solidFill>
                 <a:latin typeface="Syne" pitchFamily="34" charset="0"/>
                 <a:ea typeface="Syne" pitchFamily="34" charset="-122"/>
                 <a:cs typeface="Syne" pitchFamily="34" charset="-120"/>
               </a:rPr>
-              <a:t>retrievable</a:t>
-            </a:r>
-            <a:pPr algn="ctr" indent="0" marL="0">
-              <a:buNone/>
-            </a:pPr>
-            <a:r>
-              <a:rPr lang="en-US" sz="3800" b="1" dirty="0">
-                <a:solidFill>
-                  <a:srgbClr val="FFFFFF"/>
+              <a:t>Making the famous systems actually run</a:t>
+            </a:r>
+            <a:endParaRPr lang="en-US" sz="2400" dirty="0"/>
+          </a:p>
+        </p:txBody>
+      </p:sp>
+      <p:sp>
+        <p:nvSpPr>
+          <p:cNvPr id="4" name="Text 2"/>
+          <p:cNvSpPr/>
+          <p:nvPr/>
+        </p:nvSpPr>
+        <p:spPr>
+          <a:xfrm>
+            <a:off x="548640" y="1463040"/>
+            <a:ext cx="8046720" cy="914400"/>
+          </a:xfrm>
+          <a:prstGeom prst="rect">
+            <a:avLst/>
+          </a:prstGeom>
+          <a:noFill/>
+          <a:ln/>
+        </p:spPr>
+        <p:txBody>
+          <a:bodyPr wrap="square" lIns="0" tIns="0" rIns="0" bIns="0" rtlCol="0" anchor="ctr"/>
+          <a:lstStyle/>
+          <a:p>
+            <a:pPr indent="0" marL="0">
+              <a:buNone/>
+            </a:pPr>
+            <a:r>
+              <a:rPr lang="en-US" sz="4000" b="1" dirty="0">
+                <a:solidFill>
+                  <a:srgbClr val="9378FF"/>
                 </a:solidFill>
                 <a:latin typeface="Syne" pitchFamily="34" charset="0"/>
                 <a:ea typeface="Syne" pitchFamily="34" charset="-122"/>
                 <a:cs typeface="Syne" pitchFamily="34" charset="-120"/>
               </a:rPr>
-              <a:t>.</a:t>
-            </a:r>
-            <a:endParaRPr lang="en-US" sz="3800" dirty="0"/>
-          </a:p>
-        </p:txBody>
-      </p:sp>
-      <p:sp>
-        <p:nvSpPr>
-          <p:cNvPr id="3" name="Text 1"/>
-          <p:cNvSpPr/>
-          <p:nvPr/>
-        </p:nvSpPr>
-        <p:spPr>
-          <a:xfrm>
-            <a:off x="1188720" y="2926080"/>
-            <a:ext cx="6766560" cy="731520"/>
-          </a:xfrm>
-          <a:prstGeom prst="rect">
-            <a:avLst/>
-          </a:prstGeom>
-          <a:noFill/>
-          <a:ln/>
-        </p:spPr>
-        <p:txBody>
-          <a:bodyPr wrap="square" lIns="0" tIns="0" rIns="0" bIns="0" rtlCol="0" anchor="ctr"/>
-          <a:lstStyle/>
-          <a:p>
-            <a:pPr algn="ctr" indent="0" marL="0">
-              <a:buNone/>
-            </a:pPr>
-            <a:r>
-              <a:rPr lang="en-US" sz="1500" dirty="0">
-                <a:solidFill>
-                  <a:srgbClr val="CADCFC"/>
+              <a:t>py3.9. torch. input_type.</a:t>
+            </a:r>
+            <a:endParaRPr lang="en-US" sz="4000" dirty="0"/>
+          </a:p>
+        </p:txBody>
+      </p:sp>
+      <p:sp>
+        <p:nvSpPr>
+          <p:cNvPr id="5" name="Text 3"/>
+          <p:cNvSpPr/>
+          <p:nvPr/>
+        </p:nvSpPr>
+        <p:spPr>
+          <a:xfrm>
+            <a:off x="548640" y="2606040"/>
+            <a:ext cx="8046720" cy="1097280"/>
+          </a:xfrm>
+          <a:prstGeom prst="rect">
+            <a:avLst/>
+          </a:prstGeom>
+          <a:noFill/>
+          <a:ln/>
+        </p:spPr>
+        <p:txBody>
+          <a:bodyPr wrap="square" lIns="0" tIns="0" rIns="0" bIns="0" rtlCol="0" anchor="ctr"/>
+          <a:lstStyle/>
+          <a:p>
+            <a:pPr indent="0" marL="0">
+              <a:buNone/>
+            </a:pPr>
+            <a:r>
+              <a:rPr lang="en-US" sz="1600" dirty="0">
+                <a:solidFill>
+                  <a:srgbClr val="2E2C32"/>
                 </a:solidFill>
                 <a:latin typeface="Manrope" pitchFamily="34" charset="0"/>
                 <a:ea typeface="Manrope" pitchFamily="34" charset="-122"/>
                 <a:cs typeface="Manrope" pitchFamily="34" charset="-120"/>
               </a:rPr>
-              <a:t>One principle survives task type and model size: forget cheaply in-window, but keep the detail recoverable.</a:t>
-            </a:r>
-            <a:endParaRPr lang="en-US" sz="1500" dirty="0"/>
+              <a:t>nv-embedqa needs an input_type the stock client never sends. Torch too old for the GPU embedders. Mem0's vector store would not import on Python 3.9.</a:t>
+            </a:r>
+            <a:endParaRPr lang="en-US" sz="1600" dirty="0"/>
+          </a:p>
+        </p:txBody>
+      </p:sp>
+      <p:sp>
+        <p:nvSpPr>
+          <p:cNvPr id="6" name="Shape 4"/>
+          <p:cNvSpPr/>
+          <p:nvPr/>
+        </p:nvSpPr>
+        <p:spPr>
+          <a:xfrm>
+            <a:off x="548640" y="3886200"/>
+            <a:ext cx="91440" cy="457200"/>
+          </a:xfrm>
+          <a:prstGeom prst="rect">
+            <a:avLst/>
+          </a:prstGeom>
+          <a:solidFill>
+            <a:srgbClr val="9378FF"/>
+          </a:solidFill>
+          <a:ln/>
+        </p:spPr>
+      </p:sp>
+      <p:sp>
+        <p:nvSpPr>
+          <p:cNvPr id="7" name="Text 5"/>
+          <p:cNvSpPr/>
+          <p:nvPr/>
+        </p:nvSpPr>
+        <p:spPr>
+          <a:xfrm>
+            <a:off x="768096" y="3886200"/>
+            <a:ext cx="7863840" cy="457200"/>
+          </a:xfrm>
+          <a:prstGeom prst="rect">
+            <a:avLst/>
+          </a:prstGeom>
+          <a:noFill/>
+          <a:ln/>
+        </p:spPr>
+        <p:txBody>
+          <a:bodyPr wrap="square" lIns="0" tIns="0" rIns="0" bIns="0" rtlCol="0" anchor="ctr"/>
+          <a:lstStyle/>
+          <a:p>
+            <a:pPr indent="0" marL="0">
+              <a:buNone/>
+            </a:pPr>
+            <a:r>
+              <a:rPr lang="en-US" sz="1400" b="1" dirty="0">
+                <a:solidFill>
+                  <a:srgbClr val="7B5EF0"/>
+                </a:solidFill>
+                <a:latin typeface="Manrope" pitchFamily="34" charset="0"/>
+                <a:ea typeface="Manrope" pitchFamily="34" charset="-122"/>
+                <a:cs typeface="Manrope" pitchFamily="34" charset="-120"/>
+              </a:rPr>
+              <a:t>Lesson  </a:t>
+            </a:r>
+            <a:pPr indent="0" marL="0">
+              <a:buNone/>
+            </a:pPr>
+            <a:r>
+              <a:rPr lang="en-US" sz="1400" dirty="0">
+                <a:solidFill>
+                  <a:srgbClr val="655E74"/>
+                </a:solidFill>
+                <a:latin typeface="Manrope" pitchFamily="34" charset="0"/>
+                <a:ea typeface="Manrope" pitchFamily="34" charset="-122"/>
+                <a:cs typeface="Manrope" pitchFamily="34" charset="-120"/>
+              </a:rPr>
+              <a:t>Half of 'use the famous system' is making it run at all.</a:t>
+            </a:r>
+            <a:endParaRPr lang="en-US" sz="1400" dirty="0"/>
           </a:p>
         </p:txBody>
       </p:sp>
       <p:pic>
         <p:nvPicPr>
-          <p:cNvPr id="4" name="Image 0" descr="preencoded.png">    </p:cNvPr>
+          <p:cNvPr id="8" name="Image 0" descr="preencoded.png">    </p:cNvPr>
           <p:cNvPicPr>
             <a:picLocks noChangeAspect="1"/>
           </p:cNvPicPr>
@@ -3188,7 +3573,7 @@
       </p:pic>
       <p:sp>
         <p:nvSpPr>
-          <p:cNvPr id="5" name="Text 2"/>
+          <p:cNvPr id="9" name="Text 6"/>
           <p:cNvSpPr/>
           <p:nvPr/>
         </p:nvSpPr>
@@ -3213,7 +3598,7 @@
             <a:r>
               <a:rPr lang="en-US" sz="1100" b="1" dirty="0">
                 <a:solidFill>
-                  <a:srgbClr val="FFFFFF"/>
+                  <a:srgbClr val="2E2C32"/>
                 </a:solidFill>
                 <a:latin typeface="Syne" pitchFamily="34" charset="0"/>
                 <a:ea typeface="Syne" pitchFamily="34" charset="-122"/>
@@ -3241,7 +3626,7 @@
       </p:sp>
       <p:sp>
         <p:nvSpPr>
-          <p:cNvPr id="6" name="Text 3"/>
+          <p:cNvPr id="10" name="Text 7"/>
           <p:cNvSpPr/>
           <p:nvPr/>
         </p:nvSpPr>
@@ -3343,7 +3728,7 @@
                 <a:ea typeface="Syne" pitchFamily="34" charset="-122"/>
                 <a:cs typeface="Syne" pitchFamily="34" charset="-120"/>
               </a:rPr>
-              <a:t>HOW TO CHECK ME</a:t>
+              <a:t>AND SO WHAT?</a:t>
             </a:r>
             <a:endParaRPr lang="en-US" sz="1100" dirty="0"/>
           </a:p>
@@ -3374,7 +3759,7 @@
               <a:buNone/>
             </a:pPr>
             <a:r>
-              <a:rPr lang="en-US" sz="2500" b="1" dirty="0">
+              <a:rPr lang="en-US" sz="2400" b="1" dirty="0">
                 <a:solidFill>
                   <a:srgbClr val="2E2C32"/>
                 </a:solidFill>
@@ -3382,9 +3767,9 @@
                 <a:ea typeface="Syne" pitchFamily="34" charset="-122"/>
                 <a:cs typeface="Syne" pitchFamily="34" charset="-120"/>
               </a:rPr>
-              <a:t>Every number is a folder you can open.</a:t>
-            </a:r>
-            <a:endParaRPr lang="en-US" sz="2500" dirty="0"/>
+              <a:t>The best way to forget depends on the task.</a:t>
+            </a:r>
+            <a:endParaRPr lang="en-US" sz="2400" dirty="0"/>
           </a:p>
         </p:txBody>
       </p:sp>
@@ -3504,16 +3889,40 @@
           </a:p>
         </p:txBody>
       </p:sp>
-      <p:sp>
-        <p:nvSpPr>
-          <p:cNvPr id="7" name="Text 4"/>
-          <p:cNvSpPr/>
-          <p:nvPr/>
-        </p:nvSpPr>
-        <p:spPr>
-          <a:xfrm>
-            <a:off x="548640" y="1737360"/>
-            <a:ext cx="8046720" cy="2743200"/>
+      <p:pic>
+        <p:nvPicPr>
+          <p:cNvPr id="7" name="Image 1" descr="/Users/kanishk/Desktop/agent-harness/presentation/figures/EXP-004_transfer_v1.png">    </p:cNvPr>
+          <p:cNvPicPr>
+            <a:picLocks noChangeAspect="1"/>
+          </p:cNvPicPr>
+          <p:nvPr/>
+        </p:nvPicPr>
+        <p:blipFill>
+          <a:blip r:embed="rId2"/>
+          <a:stretch>
+            <a:fillRect/>
+          </a:stretch>
+        </p:blipFill>
+        <p:spPr>
+          <a:xfrm>
+            <a:off x="640080" y="1371600"/>
+            <a:ext cx="4846320" cy="3291840"/>
+          </a:xfrm>
+          <a:prstGeom prst="rect">
+            <a:avLst/>
+          </a:prstGeom>
+        </p:spPr>
+      </p:pic>
+      <p:sp>
+        <p:nvSpPr>
+          <p:cNvPr id="8" name="Text 4"/>
+          <p:cNvSpPr/>
+          <p:nvPr/>
+        </p:nvSpPr>
+        <p:spPr>
+          <a:xfrm>
+            <a:off x="5669280" y="1508760"/>
+            <a:ext cx="3017520" cy="2743200"/>
           </a:xfrm>
           <a:prstGeom prst="rect">
             <a:avLst/>
@@ -3533,7 +3942,7 @@
               <a:buChar char="•"/>
             </a:pPr>
             <a:r>
-              <a:rPr lang="en-US" sz="1350" dirty="0">
+              <a:rPr lang="en-US" sz="1250" dirty="0">
                 <a:solidFill>
                   <a:srgbClr val="2E2C32"/>
                 </a:solidFill>
@@ -3541,9 +3950,9 @@
                 <a:ea typeface="Manrope" pitchFamily="34" charset="-122"/>
                 <a:cs typeface="Manrope" pitchFamily="34" charset="-120"/>
               </a:rPr>
-              <a:t>Each run: experiments/runs/EXP-NNN__slug__UTC/ — config + git sha, every prompt and response, results.csv, the figure.</a:t>
-            </a:r>
-            <a:endParaRPr lang="en-US" sz="1350" dirty="0"/>
+              <a:t>Same 7 policies, two task types, three model sizes.</a:t>
+            </a:r>
+            <a:endParaRPr lang="en-US" sz="1250" dirty="0"/>
           </a:p>
           <a:p>
             <a:pPr marL="203200" indent="-203200">
@@ -3554,7 +3963,7 @@
               <a:buChar char="•"/>
             </a:pPr>
             <a:r>
-              <a:rPr lang="en-US" sz="1350" dirty="0">
+              <a:rPr lang="en-US" sz="1250" dirty="0">
                 <a:solidFill>
                   <a:srgbClr val="2E2C32"/>
                 </a:solidFill>
@@ -3562,9 +3971,9 @@
                 <a:ea typeface="Manrope" pitchFamily="34" charset="-122"/>
                 <a:cs typeface="Manrope" pitchFamily="34" charset="-120"/>
               </a:rPr>
-              <a:t>Bootstrap CIs + McNemar tests (experiments/stats.py); seeded; rate-limited + cached so re-runs are free.</a:t>
-            </a:r>
-            <a:endParaRPr lang="en-US" sz="1350" dirty="0"/>
+              <a:t>The ranking INVERTS: summarize for factual, keep-the-raw for memory.</a:t>
+            </a:r>
+            <a:endParaRPr lang="en-US" sz="1250" dirty="0"/>
           </a:p>
           <a:p>
             <a:pPr marL="203200" indent="-203200">
@@ -3575,7 +3984,7 @@
               <a:buChar char="•"/>
             </a:pPr>
             <a:r>
-              <a:rPr lang="en-US" sz="1150" dirty="0">
+              <a:rPr lang="en-US" sz="1050" dirty="0">
                 <a:solidFill>
                   <a:srgbClr val="655E74"/>
                 </a:solidFill>
@@ -3583,9 +3992,9 @@
                 <a:ea typeface="Manrope" pitchFamily="34" charset="-122"/>
                 <a:cs typeface="Manrope" pitchFamily="34" charset="-120"/>
               </a:rPr>
-              <a:t>The bar: a stranger clones the repo and regenerates any figure. The whole study cost $0 (free NIM API).</a:t>
-            </a:r>
-            <a:endParaRPr lang="en-US" sz="1350" dirty="0"/>
+              <a:t>The one policy never in the loser group keeps BOTH a summary and the raw.</a:t>
+            </a:r>
+            <a:endParaRPr lang="en-US" sz="1250" dirty="0"/>
           </a:p>
           <a:p>
             <a:pPr marL="203200" indent="-203200">
@@ -3596,7 +4005,7 @@
               <a:buChar char="•"/>
             </a:pPr>
             <a:r>
-              <a:rPr lang="en-US" sz="1350" dirty="0">
+              <a:rPr lang="en-US" sz="1250" dirty="0">
                 <a:solidFill>
                   <a:srgbClr val="2E2C32"/>
                 </a:solidFill>
@@ -3604,9 +4013,9 @@
                 <a:ea typeface="Manrope" pitchFamily="34" charset="-122"/>
                 <a:cs typeface="Manrope" pitchFamily="34" charset="-120"/>
               </a:rPr>
-              <a:t>DECISIONS.md logs every call we made and every one we changed.</a:t>
-            </a:r>
-            <a:endParaRPr lang="en-US" sz="1350" dirty="0"/>
+              <a:t>Error bars are bootstrap 95% CIs (FRAMES is still noisy at n=30).</a:t>
+            </a:r>
+            <a:endParaRPr lang="en-US" sz="1250" dirty="0"/>
           </a:p>
         </p:txBody>
       </p:sp>
@@ -3621,6 +4030,409 @@
 <file path=ppt/slides/slide14.xml><?xml version="1.0" encoding="utf-8"?>
 <p:sld xmlns:a="http://schemas.openxmlformats.org/drawingml/2006/main" xmlns:r="http://schemas.openxmlformats.org/officeDocument/2006/relationships" xmlns:p="http://schemas.openxmlformats.org/presentationml/2006/main">
   <p:cSld name="Slide 14">
+    <p:bg>
+      <p:bgPr>
+        <a:solidFill>
+          <a:srgbClr val="FAFAFE"/>
+        </a:solidFill>
+      </p:bgPr>
+    </p:bg>
+    <p:spTree>
+      <p:nvGrpSpPr>
+        <p:cNvPr id="1" name=""/>
+        <p:cNvGrpSpPr/>
+        <p:nvPr/>
+      </p:nvGrpSpPr>
+      <p:grpSpPr>
+        <a:xfrm>
+          <a:off x="0" y="0"/>
+          <a:ext cx="0" cy="0"/>
+          <a:chOff x="0" y="0"/>
+          <a:chExt cx="0" cy="0"/>
+        </a:xfrm>
+      </p:grpSpPr>
+      <p:sp>
+        <p:nvSpPr>
+          <p:cNvPr id="2" name="Text 0"/>
+          <p:cNvSpPr/>
+          <p:nvPr/>
+        </p:nvSpPr>
+        <p:spPr>
+          <a:xfrm>
+            <a:off x="548640" y="365760"/>
+            <a:ext cx="8046720" cy="274320"/>
+          </a:xfrm>
+          <a:prstGeom prst="rect">
+            <a:avLst/>
+          </a:prstGeom>
+          <a:noFill/>
+          <a:ln/>
+        </p:spPr>
+        <p:txBody>
+          <a:bodyPr wrap="square" lIns="0" tIns="0" rIns="0" bIns="0" rtlCol="0" anchor="ctr"/>
+          <a:lstStyle/>
+          <a:p>
+            <a:pPr indent="0" marL="0">
+              <a:buNone/>
+            </a:pPr>
+            <a:r>
+              <a:rPr lang="en-US" sz="1100" b="1" spc="300" kern="0" dirty="0">
+                <a:solidFill>
+                  <a:srgbClr val="9378FF"/>
+                </a:solidFill>
+                <a:latin typeface="Syne" pitchFamily="34" charset="0"/>
+                <a:ea typeface="Syne" pitchFamily="34" charset="-122"/>
+                <a:cs typeface="Syne" pitchFamily="34" charset="-120"/>
+              </a:rPr>
+              <a:t>AND SO WHAT?</a:t>
+            </a:r>
+            <a:endParaRPr lang="en-US" sz="1100" dirty="0"/>
+          </a:p>
+        </p:txBody>
+      </p:sp>
+      <p:sp>
+        <p:nvSpPr>
+          <p:cNvPr id="3" name="Text 1"/>
+          <p:cNvSpPr/>
+          <p:nvPr/>
+        </p:nvSpPr>
+        <p:spPr>
+          <a:xfrm>
+            <a:off x="548640" y="640080"/>
+            <a:ext cx="8046720" cy="822960"/>
+          </a:xfrm>
+          <a:prstGeom prst="rect">
+            <a:avLst/>
+          </a:prstGeom>
+          <a:noFill/>
+          <a:ln/>
+        </p:spPr>
+        <p:txBody>
+          <a:bodyPr wrap="square" lIns="0" tIns="0" rIns="0" bIns="0" rtlCol="0" anchor="t"/>
+          <a:lstStyle/>
+          <a:p>
+            <a:pPr indent="0" marL="0">
+              <a:buNone/>
+            </a:pPr>
+            <a:r>
+              <a:rPr lang="en-US" sz="2400" b="1" dirty="0">
+                <a:solidFill>
+                  <a:srgbClr val="2E2C32"/>
+                </a:solidFill>
+                <a:latin typeface="Syne" pitchFamily="34" charset="0"/>
+                <a:ea typeface="Syne" pitchFamily="34" charset="-122"/>
+                <a:cs typeface="Syne" pitchFamily="34" charset="-120"/>
+              </a:rPr>
+              <a:t>The policy that ships in most agents is weak.</a:t>
+            </a:r>
+            <a:endParaRPr lang="en-US" sz="2400" dirty="0"/>
+          </a:p>
+        </p:txBody>
+      </p:sp>
+      <p:pic>
+        <p:nvPicPr>
+          <p:cNvPr id="4" name="Image 0" descr="preencoded.png">    </p:cNvPr>
+          <p:cNvPicPr>
+            <a:picLocks noChangeAspect="1"/>
+          </p:cNvPicPr>
+          <p:nvPr/>
+        </p:nvPicPr>
+        <p:blipFill>
+          <a:blip r:embed="rId1"/>
+          <a:stretch>
+            <a:fillRect/>
+          </a:stretch>
+        </p:blipFill>
+        <p:spPr>
+          <a:xfrm>
+            <a:off x="548640" y="4736592"/>
+            <a:ext cx="219456" cy="165344"/>
+          </a:xfrm>
+          <a:prstGeom prst="rect">
+            <a:avLst/>
+          </a:prstGeom>
+        </p:spPr>
+      </p:pic>
+      <p:sp>
+        <p:nvSpPr>
+          <p:cNvPr id="5" name="Text 2"/>
+          <p:cNvSpPr/>
+          <p:nvPr/>
+        </p:nvSpPr>
+        <p:spPr>
+          <a:xfrm>
+            <a:off x="822960" y="4690872"/>
+            <a:ext cx="1280160" cy="292608"/>
+          </a:xfrm>
+          <a:prstGeom prst="rect">
+            <a:avLst/>
+          </a:prstGeom>
+          <a:noFill/>
+          <a:ln/>
+        </p:spPr>
+        <p:txBody>
+          <a:bodyPr wrap="square" lIns="0" tIns="0" rIns="0" bIns="0" rtlCol="0" anchor="ctr"/>
+          <a:lstStyle/>
+          <a:p>
+            <a:pPr indent="0" marL="0">
+              <a:buNone/>
+            </a:pPr>
+            <a:r>
+              <a:rPr lang="en-US" sz="1100" b="1" dirty="0">
+                <a:solidFill>
+                  <a:srgbClr val="2E2C32"/>
+                </a:solidFill>
+                <a:latin typeface="Syne" pitchFamily="34" charset="0"/>
+                <a:ea typeface="Syne" pitchFamily="34" charset="-122"/>
+                <a:cs typeface="Syne" pitchFamily="34" charset="-120"/>
+              </a:rPr>
+              <a:t>Founsi</a:t>
+            </a:r>
+            <a:pPr indent="0" marL="0">
+              <a:buNone/>
+            </a:pPr>
+            <a:r>
+              <a:rPr lang="en-US" sz="1100" b="1" dirty="0">
+                <a:solidFill>
+                  <a:srgbClr val="9378FF"/>
+                </a:solidFill>
+                <a:latin typeface="Syne" pitchFamily="34" charset="0"/>
+                <a:ea typeface="Syne" pitchFamily="34" charset="-122"/>
+                <a:cs typeface="Syne" pitchFamily="34" charset="-120"/>
+              </a:rPr>
+              <a:t>.</a:t>
+            </a:r>
+            <a:endParaRPr lang="en-US" sz="1100" dirty="0"/>
+          </a:p>
+        </p:txBody>
+      </p:sp>
+      <p:sp>
+        <p:nvSpPr>
+          <p:cNvPr id="6" name="Text 3"/>
+          <p:cNvSpPr/>
+          <p:nvPr/>
+        </p:nvSpPr>
+        <p:spPr>
+          <a:xfrm>
+            <a:off x="8229600" y="4690872"/>
+            <a:ext cx="365760" cy="292608"/>
+          </a:xfrm>
+          <a:prstGeom prst="rect">
+            <a:avLst/>
+          </a:prstGeom>
+          <a:noFill/>
+          <a:ln/>
+        </p:spPr>
+        <p:txBody>
+          <a:bodyPr wrap="square" lIns="0" tIns="0" rIns="0" bIns="0" rtlCol="0" anchor="ctr"/>
+          <a:lstStyle/>
+          <a:p>
+            <a:pPr algn="r" indent="0" marL="0">
+              <a:buNone/>
+            </a:pPr>
+            <a:r>
+              <a:rPr lang="en-US" sz="900" dirty="0">
+                <a:solidFill>
+                  <a:srgbClr val="7E7A8A"/>
+                </a:solidFill>
+                <a:latin typeface="Manrope" pitchFamily="34" charset="0"/>
+                <a:ea typeface="Manrope" pitchFamily="34" charset="-122"/>
+                <a:cs typeface="Manrope" pitchFamily="34" charset="-120"/>
+              </a:rPr>
+              <a:t>14</a:t>
+            </a:r>
+            <a:endParaRPr lang="en-US" sz="900" dirty="0"/>
+          </a:p>
+        </p:txBody>
+      </p:sp>
+      <p:sp>
+        <p:nvSpPr>
+          <p:cNvPr id="7" name="Shape 4"/>
+          <p:cNvSpPr/>
+          <p:nvPr/>
+        </p:nvSpPr>
+        <p:spPr>
+          <a:xfrm>
+            <a:off x="640080" y="1645920"/>
+            <a:ext cx="7863840" cy="868680"/>
+          </a:xfrm>
+          <a:prstGeom prst="rect">
+            <a:avLst/>
+          </a:prstGeom>
+          <a:solidFill>
+            <a:srgbClr val="F4F2F8"/>
+          </a:solidFill>
+          <a:ln w="12700">
+            <a:solidFill>
+              <a:srgbClr val="D4C9FF"/>
+            </a:solidFill>
+            <a:prstDash val="solid"/>
+          </a:ln>
+        </p:spPr>
+      </p:sp>
+      <p:sp>
+        <p:nvSpPr>
+          <p:cNvPr id="8" name="Text 5"/>
+          <p:cNvSpPr/>
+          <p:nvPr/>
+        </p:nvSpPr>
+        <p:spPr>
+          <a:xfrm>
+            <a:off x="822960" y="1645920"/>
+            <a:ext cx="7498080" cy="868680"/>
+          </a:xfrm>
+          <a:prstGeom prst="rect">
+            <a:avLst/>
+          </a:prstGeom>
+          <a:noFill/>
+          <a:ln/>
+        </p:spPr>
+        <p:txBody>
+          <a:bodyPr wrap="square" lIns="0" tIns="0" rIns="0" bIns="0" rtlCol="0" anchor="ctr"/>
+          <a:lstStyle/>
+          <a:p>
+            <a:pPr indent="0" marL="0">
+              <a:buNone/>
+            </a:pPr>
+            <a:r>
+              <a:rPr lang="en-US" sz="1800" b="1" dirty="0">
+                <a:solidFill>
+                  <a:srgbClr val="2E2C32"/>
+                </a:solidFill>
+                <a:latin typeface="Manrope" pitchFamily="34" charset="0"/>
+                <a:ea typeface="Manrope" pitchFamily="34" charset="-122"/>
+                <a:cs typeface="Manrope" pitchFamily="34" charset="-120"/>
+              </a:rPr>
+              <a:t>recency summary  </a:t>
+            </a:r>
+            <a:pPr indent="0" marL="0">
+              <a:buNone/>
+            </a:pPr>
+            <a:r>
+              <a:rPr lang="en-US" sz="1600" dirty="0">
+                <a:solidFill>
+                  <a:srgbClr val="655E74"/>
+                </a:solidFill>
+                <a:latin typeface="Manrope" pitchFamily="34" charset="0"/>
+                <a:ea typeface="Manrope" pitchFamily="34" charset="-122"/>
+                <a:cs typeface="Manrope" pitchFamily="34" charset="-120"/>
+              </a:rPr>
+              <a:t>= truncation's accuracy,  </a:t>
+            </a:r>
+            <a:pPr indent="0" marL="0">
+              <a:buNone/>
+            </a:pPr>
+            <a:r>
+              <a:rPr lang="en-US" sz="1800" b="1" dirty="0">
+                <a:solidFill>
+                  <a:srgbClr val="A32D2D"/>
+                </a:solidFill>
+                <a:latin typeface="Manrope" pitchFamily="34" charset="0"/>
+                <a:ea typeface="Manrope" pitchFamily="34" charset="-122"/>
+                <a:cs typeface="Manrope" pitchFamily="34" charset="-120"/>
+              </a:rPr>
+              <a:t>7× the cost.</a:t>
+            </a:r>
+            <a:endParaRPr lang="en-US" sz="1800" dirty="0"/>
+          </a:p>
+        </p:txBody>
+      </p:sp>
+      <p:sp>
+        <p:nvSpPr>
+          <p:cNvPr id="9" name="Text 6"/>
+          <p:cNvSpPr/>
+          <p:nvPr/>
+        </p:nvSpPr>
+        <p:spPr>
+          <a:xfrm>
+            <a:off x="548640" y="2788920"/>
+            <a:ext cx="8046720" cy="2743200"/>
+          </a:xfrm>
+          <a:prstGeom prst="rect">
+            <a:avLst/>
+          </a:prstGeom>
+          <a:noFill/>
+          <a:ln/>
+        </p:spPr>
+        <p:txBody>
+          <a:bodyPr wrap="square" rtlCol="0" anchor="ctr"/>
+          <a:lstStyle/>
+          <a:p>
+            <a:pPr marL="203200" indent="-203200">
+              <a:spcAft>
+                <a:spcPts val="900"/>
+              </a:spcAft>
+              <a:buSzPct val="100000"/>
+              <a:buChar char="•"/>
+            </a:pPr>
+            <a:r>
+              <a:rPr lang="en-US" sz="1400" dirty="0">
+                <a:solidFill>
+                  <a:srgbClr val="2E2C32"/>
+                </a:solidFill>
+                <a:latin typeface="Manrope" pitchFamily="34" charset="0"/>
+                <a:ea typeface="Manrope" pitchFamily="34" charset="-122"/>
+                <a:cs typeface="Manrope" pitchFamily="34" charset="-120"/>
+              </a:rPr>
+              <a:t>Summarizing the stale middle bought nothing over just dropping it, under pressure.</a:t>
+            </a:r>
+            <a:endParaRPr lang="en-US" sz="1400" dirty="0"/>
+          </a:p>
+          <a:p>
+            <a:pPr marL="203200" indent="-203200">
+              <a:spcAft>
+                <a:spcPts val="900"/>
+              </a:spcAft>
+              <a:buSzPct val="100000"/>
+              <a:buChar char="•"/>
+            </a:pPr>
+            <a:r>
+              <a:rPr lang="en-US" sz="1400" dirty="0">
+                <a:solidFill>
+                  <a:srgbClr val="2E2C32"/>
+                </a:solidFill>
+                <a:latin typeface="Manrope" pitchFamily="34" charset="0"/>
+                <a:ea typeface="Manrope" pitchFamily="34" charset="-122"/>
+                <a:cs typeface="Manrope" pitchFamily="34" charset="-120"/>
+              </a:rPr>
+              <a:t>Sub-agent isolation: same accuracy as keeping turns, 5× the cost. A trap on this task.</a:t>
+            </a:r>
+            <a:endParaRPr lang="en-US" sz="1400" dirty="0"/>
+          </a:p>
+          <a:p>
+            <a:pPr marL="203200" indent="-203200">
+              <a:spcAft>
+                <a:spcPts val="900"/>
+              </a:spcAft>
+              <a:buSzPct val="100000"/>
+              <a:buChar char="•"/>
+            </a:pPr>
+            <a:r>
+              <a:rPr lang="en-US" sz="1200" dirty="0">
+                <a:solidFill>
+                  <a:srgbClr val="655E74"/>
+                </a:solidFill>
+                <a:latin typeface="Manrope" pitchFamily="34" charset="0"/>
+                <a:ea typeface="Manrope" pitchFamily="34" charset="-122"/>
+                <a:cs typeface="Manrope" pitchFamily="34" charset="-120"/>
+              </a:rPr>
+              <a:t>Both are cost-normalized negatives that anyone running agents can use today.</a:t>
+            </a:r>
+            <a:endParaRPr lang="en-US" sz="1400" dirty="0"/>
+          </a:p>
+        </p:txBody>
+      </p:sp>
+    </p:spTree>
+  </p:cSld>
+  <p:clrMapOvr>
+    <a:masterClrMapping/>
+  </p:clrMapOvr>
+</p:sld>
+</file>
+
+<file path=ppt/slides/slide15.xml><?xml version="1.0" encoding="utf-8"?>
+<p:sld xmlns:a="http://schemas.openxmlformats.org/drawingml/2006/main" xmlns:r="http://schemas.openxmlformats.org/officeDocument/2006/relationships" xmlns:p="http://schemas.openxmlformats.org/presentationml/2006/main">
+  <p:cSld name="Slide 15">
     <p:bg>
       <p:bgPr>
         <a:solidFill>
@@ -3650,79 +4462,107 @@
         </p:nvSpPr>
         <p:spPr>
           <a:xfrm>
-            <a:off x="548640" y="548640"/>
-            <a:ext cx="8229600" cy="365760"/>
-          </a:xfrm>
-          <a:prstGeom prst="rect">
-            <a:avLst/>
-          </a:prstGeom>
-          <a:noFill/>
-          <a:ln/>
-        </p:spPr>
-        <p:txBody>
-          <a:bodyPr wrap="square" lIns="0" tIns="0" rIns="0" bIns="0" rtlCol="0" anchor="ctr"/>
-          <a:lstStyle/>
-          <a:p>
-            <a:pPr indent="0" marL="0">
-              <a:buNone/>
-            </a:pPr>
-            <a:r>
-              <a:rPr lang="en-US" sz="1200" b="1" spc="400" kern="0" dirty="0">
-                <a:solidFill>
-                  <a:srgbClr val="9378FF"/>
+            <a:off x="731520" y="1920240"/>
+            <a:ext cx="7680960" cy="914400"/>
+          </a:xfrm>
+          <a:prstGeom prst="rect">
+            <a:avLst/>
+          </a:prstGeom>
+          <a:noFill/>
+          <a:ln/>
+        </p:spPr>
+        <p:txBody>
+          <a:bodyPr wrap="square" lIns="0" tIns="0" rIns="0" bIns="0" rtlCol="0" anchor="ctr"/>
+          <a:lstStyle/>
+          <a:p>
+            <a:pPr algn="ctr" indent="0" marL="0">
+              <a:buNone/>
+            </a:pPr>
+            <a:r>
+              <a:rPr lang="en-US" sz="3800" b="1" dirty="0">
+                <a:solidFill>
+                  <a:srgbClr val="FFFFFF"/>
                 </a:solidFill>
                 <a:latin typeface="Syne" pitchFamily="34" charset="0"/>
                 <a:ea typeface="Syne" pitchFamily="34" charset="-122"/>
                 <a:cs typeface="Syne" pitchFamily="34" charset="-120"/>
               </a:rPr>
-              <a:t>FIND ME</a:t>
-            </a:r>
-            <a:endParaRPr lang="en-US" sz="1200" dirty="0"/>
-          </a:p>
-        </p:txBody>
-      </p:sp>
-      <p:sp>
-        <p:nvSpPr>
-          <p:cNvPr id="3" name="Text 1"/>
-          <p:cNvSpPr/>
-          <p:nvPr/>
-        </p:nvSpPr>
-        <p:spPr>
-          <a:xfrm>
-            <a:off x="548640" y="914400"/>
-            <a:ext cx="8229600" cy="640080"/>
-          </a:xfrm>
-          <a:prstGeom prst="rect">
-            <a:avLst/>
-          </a:prstGeom>
-          <a:noFill/>
-          <a:ln/>
-        </p:spPr>
-        <p:txBody>
-          <a:bodyPr wrap="square" lIns="0" tIns="0" rIns="0" bIns="0" rtlCol="0" anchor="ctr"/>
-          <a:lstStyle/>
-          <a:p>
-            <a:pPr indent="0" marL="0">
-              <a:buNone/>
-            </a:pPr>
-            <a:r>
-              <a:rPr lang="en-US" sz="3000" b="1" dirty="0">
-                <a:solidFill>
-                  <a:srgbClr val="FFFFFF"/>
+              <a:t>Keep the raw </a:t>
+            </a:r>
+            <a:pPr algn="ctr" indent="0" marL="0">
+              <a:buNone/>
+            </a:pPr>
+            <a:r>
+              <a:rPr lang="en-US" sz="3800" b="1" i="1" dirty="0">
+                <a:solidFill>
+                  <a:srgbClr val="9378FF"/>
                 </a:solidFill>
                 <a:latin typeface="Syne" pitchFamily="34" charset="0"/>
                 <a:ea typeface="Syne" pitchFamily="34" charset="-122"/>
                 <a:cs typeface="Syne" pitchFamily="34" charset="-120"/>
               </a:rPr>
-              <a:t>Clone it. Break it. Tell me I'm wrong.</a:t>
-            </a:r>
-            <a:endParaRPr lang="en-US" sz="3000" dirty="0"/>
+              <a:t>retrievable</a:t>
+            </a:r>
+            <a:pPr algn="ctr" indent="0" marL="0">
+              <a:buNone/>
+            </a:pPr>
+            <a:r>
+              <a:rPr lang="en-US" sz="3800" b="1" dirty="0">
+                <a:solidFill>
+                  <a:srgbClr val="FFFFFF"/>
+                </a:solidFill>
+                <a:latin typeface="Syne" pitchFamily="34" charset="0"/>
+                <a:ea typeface="Syne" pitchFamily="34" charset="-122"/>
+                <a:cs typeface="Syne" pitchFamily="34" charset="-120"/>
+              </a:rPr>
+              <a:t>.</a:t>
+            </a:r>
+            <a:endParaRPr lang="en-US" sz="3800" dirty="0"/>
+          </a:p>
+        </p:txBody>
+      </p:sp>
+      <p:sp>
+        <p:nvSpPr>
+          <p:cNvPr id="3" name="Text 1"/>
+          <p:cNvSpPr/>
+          <p:nvPr/>
+        </p:nvSpPr>
+        <p:spPr>
+          <a:xfrm>
+            <a:off x="1188720" y="2926080"/>
+            <a:ext cx="6766560" cy="731520"/>
+          </a:xfrm>
+          <a:prstGeom prst="rect">
+            <a:avLst/>
+          </a:prstGeom>
+          <a:noFill/>
+          <a:ln/>
+        </p:spPr>
+        <p:txBody>
+          <a:bodyPr wrap="square" lIns="0" tIns="0" rIns="0" bIns="0" rtlCol="0" anchor="ctr"/>
+          <a:lstStyle/>
+          <a:p>
+            <a:pPr algn="ctr" indent="0" marL="0">
+              <a:buNone/>
+            </a:pPr>
+            <a:r>
+              <a:rPr lang="en-US" sz="1500" dirty="0">
+                <a:solidFill>
+                  <a:srgbClr val="CADCFC"/>
+                </a:solidFill>
+                <a:latin typeface="Manrope" pitchFamily="34" charset="0"/>
+                <a:ea typeface="Manrope" pitchFamily="34" charset="-122"/>
+                <a:cs typeface="Manrope" pitchFamily="34" charset="-120"/>
+              </a:rPr>
+              <a:t>One principle survives task type, model size, and the OSS systems: forget cheaply in-window, but keep the detail recoverable.</a:t>
+            </a:r>
+            <a:endParaRPr lang="en-US" sz="1500" dirty="0"/>
           </a:p>
         </p:txBody>
       </p:sp>
       <p:pic>
         <p:nvPicPr>
-          <p:cNvPr id="4" name="Image 0" descr="/Users/kanishk/Desktop/agent-harness/presentation/assets/qr/qr_repo.png">    </p:cNvPr>
+          <p:cNvPr id="4" name="Image 0" descr="preencoded.png">    </p:cNvPr>
           <p:cNvPicPr>
             <a:picLocks noChangeAspect="1"/>
           </p:cNvPicPr>
@@ -3736,6 +4576,564 @@
         </p:blipFill>
         <p:spPr>
           <a:xfrm>
+            <a:off x="548640" y="4736592"/>
+            <a:ext cx="219456" cy="165344"/>
+          </a:xfrm>
+          <a:prstGeom prst="rect">
+            <a:avLst/>
+          </a:prstGeom>
+        </p:spPr>
+      </p:pic>
+      <p:sp>
+        <p:nvSpPr>
+          <p:cNvPr id="5" name="Text 2"/>
+          <p:cNvSpPr/>
+          <p:nvPr/>
+        </p:nvSpPr>
+        <p:spPr>
+          <a:xfrm>
+            <a:off x="822960" y="4690872"/>
+            <a:ext cx="1280160" cy="292608"/>
+          </a:xfrm>
+          <a:prstGeom prst="rect">
+            <a:avLst/>
+          </a:prstGeom>
+          <a:noFill/>
+          <a:ln/>
+        </p:spPr>
+        <p:txBody>
+          <a:bodyPr wrap="square" lIns="0" tIns="0" rIns="0" bIns="0" rtlCol="0" anchor="ctr"/>
+          <a:lstStyle/>
+          <a:p>
+            <a:pPr indent="0" marL="0">
+              <a:buNone/>
+            </a:pPr>
+            <a:r>
+              <a:rPr lang="en-US" sz="1100" b="1" dirty="0">
+                <a:solidFill>
+                  <a:srgbClr val="FFFFFF"/>
+                </a:solidFill>
+                <a:latin typeface="Syne" pitchFamily="34" charset="0"/>
+                <a:ea typeface="Syne" pitchFamily="34" charset="-122"/>
+                <a:cs typeface="Syne" pitchFamily="34" charset="-120"/>
+              </a:rPr>
+              <a:t>Founsi</a:t>
+            </a:r>
+            <a:pPr indent="0" marL="0">
+              <a:buNone/>
+            </a:pPr>
+            <a:r>
+              <a:rPr lang="en-US" sz="1100" b="1" dirty="0">
+                <a:solidFill>
+                  <a:srgbClr val="9378FF"/>
+                </a:solidFill>
+                <a:latin typeface="Syne" pitchFamily="34" charset="0"/>
+                <a:ea typeface="Syne" pitchFamily="34" charset="-122"/>
+                <a:cs typeface="Syne" pitchFamily="34" charset="-120"/>
+              </a:rPr>
+              <a:t>.</a:t>
+            </a:r>
+            <a:endParaRPr lang="en-US" sz="1100" dirty="0"/>
+          </a:p>
+        </p:txBody>
+      </p:sp>
+      <p:sp>
+        <p:nvSpPr>
+          <p:cNvPr id="6" name="Text 3"/>
+          <p:cNvSpPr/>
+          <p:nvPr/>
+        </p:nvSpPr>
+        <p:spPr>
+          <a:xfrm>
+            <a:off x="8229600" y="4690872"/>
+            <a:ext cx="365760" cy="292608"/>
+          </a:xfrm>
+          <a:prstGeom prst="rect">
+            <a:avLst/>
+          </a:prstGeom>
+          <a:noFill/>
+          <a:ln/>
+        </p:spPr>
+        <p:txBody>
+          <a:bodyPr wrap="square" lIns="0" tIns="0" rIns="0" bIns="0" rtlCol="0" anchor="ctr"/>
+          <a:lstStyle/>
+          <a:p>
+            <a:pPr algn="r" indent="0" marL="0">
+              <a:buNone/>
+            </a:pPr>
+            <a:r>
+              <a:rPr lang="en-US" sz="900" dirty="0">
+                <a:solidFill>
+                  <a:srgbClr val="7E7A8A"/>
+                </a:solidFill>
+                <a:latin typeface="Manrope" pitchFamily="34" charset="0"/>
+                <a:ea typeface="Manrope" pitchFamily="34" charset="-122"/>
+                <a:cs typeface="Manrope" pitchFamily="34" charset="-120"/>
+              </a:rPr>
+              <a:t>15</a:t>
+            </a:r>
+            <a:endParaRPr lang="en-US" sz="900" dirty="0"/>
+          </a:p>
+        </p:txBody>
+      </p:sp>
+    </p:spTree>
+  </p:cSld>
+  <p:clrMapOvr>
+    <a:masterClrMapping/>
+  </p:clrMapOvr>
+</p:sld>
+</file>
+
+<file path=ppt/slides/slide16.xml><?xml version="1.0" encoding="utf-8"?>
+<p:sld xmlns:a="http://schemas.openxmlformats.org/drawingml/2006/main" xmlns:r="http://schemas.openxmlformats.org/officeDocument/2006/relationships" xmlns:p="http://schemas.openxmlformats.org/presentationml/2006/main">
+  <p:cSld name="Slide 16">
+    <p:bg>
+      <p:bgPr>
+        <a:solidFill>
+          <a:srgbClr val="FAFAFE"/>
+        </a:solidFill>
+      </p:bgPr>
+    </p:bg>
+    <p:spTree>
+      <p:nvGrpSpPr>
+        <p:cNvPr id="1" name=""/>
+        <p:cNvGrpSpPr/>
+        <p:nvPr/>
+      </p:nvGrpSpPr>
+      <p:grpSpPr>
+        <a:xfrm>
+          <a:off x="0" y="0"/>
+          <a:ext cx="0" cy="0"/>
+          <a:chOff x="0" y="0"/>
+          <a:chExt cx="0" cy="0"/>
+        </a:xfrm>
+      </p:grpSpPr>
+      <p:sp>
+        <p:nvSpPr>
+          <p:cNvPr id="2" name="Text 0"/>
+          <p:cNvSpPr/>
+          <p:nvPr/>
+        </p:nvSpPr>
+        <p:spPr>
+          <a:xfrm>
+            <a:off x="548640" y="365760"/>
+            <a:ext cx="8046720" cy="274320"/>
+          </a:xfrm>
+          <a:prstGeom prst="rect">
+            <a:avLst/>
+          </a:prstGeom>
+          <a:noFill/>
+          <a:ln/>
+        </p:spPr>
+        <p:txBody>
+          <a:bodyPr wrap="square" lIns="0" tIns="0" rIns="0" bIns="0" rtlCol="0" anchor="ctr"/>
+          <a:lstStyle/>
+          <a:p>
+            <a:pPr indent="0" marL="0">
+              <a:buNone/>
+            </a:pPr>
+            <a:r>
+              <a:rPr lang="en-US" sz="1100" b="1" spc="300" kern="0" dirty="0">
+                <a:solidFill>
+                  <a:srgbClr val="9378FF"/>
+                </a:solidFill>
+                <a:latin typeface="Syne" pitchFamily="34" charset="0"/>
+                <a:ea typeface="Syne" pitchFamily="34" charset="-122"/>
+                <a:cs typeface="Syne" pitchFamily="34" charset="-120"/>
+              </a:rPr>
+              <a:t>HOW TO CHECK ME</a:t>
+            </a:r>
+            <a:endParaRPr lang="en-US" sz="1100" dirty="0"/>
+          </a:p>
+        </p:txBody>
+      </p:sp>
+      <p:sp>
+        <p:nvSpPr>
+          <p:cNvPr id="3" name="Text 1"/>
+          <p:cNvSpPr/>
+          <p:nvPr/>
+        </p:nvSpPr>
+        <p:spPr>
+          <a:xfrm>
+            <a:off x="548640" y="640080"/>
+            <a:ext cx="8046720" cy="822960"/>
+          </a:xfrm>
+          <a:prstGeom prst="rect">
+            <a:avLst/>
+          </a:prstGeom>
+          <a:noFill/>
+          <a:ln/>
+        </p:spPr>
+        <p:txBody>
+          <a:bodyPr wrap="square" lIns="0" tIns="0" rIns="0" bIns="0" rtlCol="0" anchor="t"/>
+          <a:lstStyle/>
+          <a:p>
+            <a:pPr indent="0" marL="0">
+              <a:buNone/>
+            </a:pPr>
+            <a:r>
+              <a:rPr lang="en-US" sz="2500" b="1" dirty="0">
+                <a:solidFill>
+                  <a:srgbClr val="2E2C32"/>
+                </a:solidFill>
+                <a:latin typeface="Syne" pitchFamily="34" charset="0"/>
+                <a:ea typeface="Syne" pitchFamily="34" charset="-122"/>
+                <a:cs typeface="Syne" pitchFamily="34" charset="-120"/>
+              </a:rPr>
+              <a:t>Every number is a folder you can open.</a:t>
+            </a:r>
+            <a:endParaRPr lang="en-US" sz="2500" dirty="0"/>
+          </a:p>
+        </p:txBody>
+      </p:sp>
+      <p:pic>
+        <p:nvPicPr>
+          <p:cNvPr id="4" name="Image 0" descr="preencoded.png">    </p:cNvPr>
+          <p:cNvPicPr>
+            <a:picLocks noChangeAspect="1"/>
+          </p:cNvPicPr>
+          <p:nvPr/>
+        </p:nvPicPr>
+        <p:blipFill>
+          <a:blip r:embed="rId1"/>
+          <a:stretch>
+            <a:fillRect/>
+          </a:stretch>
+        </p:blipFill>
+        <p:spPr>
+          <a:xfrm>
+            <a:off x="548640" y="4736592"/>
+            <a:ext cx="219456" cy="165344"/>
+          </a:xfrm>
+          <a:prstGeom prst="rect">
+            <a:avLst/>
+          </a:prstGeom>
+        </p:spPr>
+      </p:pic>
+      <p:sp>
+        <p:nvSpPr>
+          <p:cNvPr id="5" name="Text 2"/>
+          <p:cNvSpPr/>
+          <p:nvPr/>
+        </p:nvSpPr>
+        <p:spPr>
+          <a:xfrm>
+            <a:off x="822960" y="4690872"/>
+            <a:ext cx="1280160" cy="292608"/>
+          </a:xfrm>
+          <a:prstGeom prst="rect">
+            <a:avLst/>
+          </a:prstGeom>
+          <a:noFill/>
+          <a:ln/>
+        </p:spPr>
+        <p:txBody>
+          <a:bodyPr wrap="square" lIns="0" tIns="0" rIns="0" bIns="0" rtlCol="0" anchor="ctr"/>
+          <a:lstStyle/>
+          <a:p>
+            <a:pPr indent="0" marL="0">
+              <a:buNone/>
+            </a:pPr>
+            <a:r>
+              <a:rPr lang="en-US" sz="1100" b="1" dirty="0">
+                <a:solidFill>
+                  <a:srgbClr val="2E2C32"/>
+                </a:solidFill>
+                <a:latin typeface="Syne" pitchFamily="34" charset="0"/>
+                <a:ea typeface="Syne" pitchFamily="34" charset="-122"/>
+                <a:cs typeface="Syne" pitchFamily="34" charset="-120"/>
+              </a:rPr>
+              <a:t>Founsi</a:t>
+            </a:r>
+            <a:pPr indent="0" marL="0">
+              <a:buNone/>
+            </a:pPr>
+            <a:r>
+              <a:rPr lang="en-US" sz="1100" b="1" dirty="0">
+                <a:solidFill>
+                  <a:srgbClr val="9378FF"/>
+                </a:solidFill>
+                <a:latin typeface="Syne" pitchFamily="34" charset="0"/>
+                <a:ea typeface="Syne" pitchFamily="34" charset="-122"/>
+                <a:cs typeface="Syne" pitchFamily="34" charset="-120"/>
+              </a:rPr>
+              <a:t>.</a:t>
+            </a:r>
+            <a:endParaRPr lang="en-US" sz="1100" dirty="0"/>
+          </a:p>
+        </p:txBody>
+      </p:sp>
+      <p:sp>
+        <p:nvSpPr>
+          <p:cNvPr id="6" name="Text 3"/>
+          <p:cNvSpPr/>
+          <p:nvPr/>
+        </p:nvSpPr>
+        <p:spPr>
+          <a:xfrm>
+            <a:off x="8229600" y="4690872"/>
+            <a:ext cx="365760" cy="292608"/>
+          </a:xfrm>
+          <a:prstGeom prst="rect">
+            <a:avLst/>
+          </a:prstGeom>
+          <a:noFill/>
+          <a:ln/>
+        </p:spPr>
+        <p:txBody>
+          <a:bodyPr wrap="square" lIns="0" tIns="0" rIns="0" bIns="0" rtlCol="0" anchor="ctr"/>
+          <a:lstStyle/>
+          <a:p>
+            <a:pPr algn="r" indent="0" marL="0">
+              <a:buNone/>
+            </a:pPr>
+            <a:r>
+              <a:rPr lang="en-US" sz="900" dirty="0">
+                <a:solidFill>
+                  <a:srgbClr val="7E7A8A"/>
+                </a:solidFill>
+                <a:latin typeface="Manrope" pitchFamily="34" charset="0"/>
+                <a:ea typeface="Manrope" pitchFamily="34" charset="-122"/>
+                <a:cs typeface="Manrope" pitchFamily="34" charset="-120"/>
+              </a:rPr>
+              <a:t>16</a:t>
+            </a:r>
+            <a:endParaRPr lang="en-US" sz="900" dirty="0"/>
+          </a:p>
+        </p:txBody>
+      </p:sp>
+      <p:sp>
+        <p:nvSpPr>
+          <p:cNvPr id="7" name="Text 4"/>
+          <p:cNvSpPr/>
+          <p:nvPr/>
+        </p:nvSpPr>
+        <p:spPr>
+          <a:xfrm>
+            <a:off x="548640" y="1737360"/>
+            <a:ext cx="8046720" cy="2743200"/>
+          </a:xfrm>
+          <a:prstGeom prst="rect">
+            <a:avLst/>
+          </a:prstGeom>
+          <a:noFill/>
+          <a:ln/>
+        </p:spPr>
+        <p:txBody>
+          <a:bodyPr wrap="square" rtlCol="0" anchor="ctr"/>
+          <a:lstStyle/>
+          <a:p>
+            <a:pPr marL="203200" indent="-203200">
+              <a:spcAft>
+                <a:spcPts val="900"/>
+              </a:spcAft>
+              <a:buSzPct val="100000"/>
+              <a:buChar char="•"/>
+            </a:pPr>
+            <a:r>
+              <a:rPr lang="en-US" sz="1350" dirty="0">
+                <a:solidFill>
+                  <a:srgbClr val="2E2C32"/>
+                </a:solidFill>
+                <a:latin typeface="Manrope" pitchFamily="34" charset="0"/>
+                <a:ea typeface="Manrope" pitchFamily="34" charset="-122"/>
+                <a:cs typeface="Manrope" pitchFamily="34" charset="-120"/>
+              </a:rPr>
+              <a:t>Each run: experiments/runs/EXP-NNN__slug__UTC/ — config + git sha, every prompt and response, results.csv, the figure.</a:t>
+            </a:r>
+            <a:endParaRPr lang="en-US" sz="1350" dirty="0"/>
+          </a:p>
+          <a:p>
+            <a:pPr marL="203200" indent="-203200">
+              <a:spcAft>
+                <a:spcPts val="900"/>
+              </a:spcAft>
+              <a:buSzPct val="100000"/>
+              <a:buChar char="•"/>
+            </a:pPr>
+            <a:r>
+              <a:rPr lang="en-US" sz="1350" dirty="0">
+                <a:solidFill>
+                  <a:srgbClr val="2E2C32"/>
+                </a:solidFill>
+                <a:latin typeface="Manrope" pitchFamily="34" charset="0"/>
+                <a:ea typeface="Manrope" pitchFamily="34" charset="-122"/>
+                <a:cs typeface="Manrope" pitchFamily="34" charset="-120"/>
+              </a:rPr>
+              <a:t>Bootstrap CIs + McNemar tests (experiments/stats.py); seeded; rate-limited + cached so re-runs are free.</a:t>
+            </a:r>
+            <a:endParaRPr lang="en-US" sz="1350" dirty="0"/>
+          </a:p>
+          <a:p>
+            <a:pPr marL="203200" indent="-203200">
+              <a:spcAft>
+                <a:spcPts val="900"/>
+              </a:spcAft>
+              <a:buSzPct val="100000"/>
+              <a:buChar char="•"/>
+            </a:pPr>
+            <a:r>
+              <a:rPr lang="en-US" sz="1150" dirty="0">
+                <a:solidFill>
+                  <a:srgbClr val="655E74"/>
+                </a:solidFill>
+                <a:latin typeface="Manrope" pitchFamily="34" charset="0"/>
+                <a:ea typeface="Manrope" pitchFamily="34" charset="-122"/>
+                <a:cs typeface="Manrope" pitchFamily="34" charset="-120"/>
+              </a:rPr>
+              <a:t>The bar: a stranger clones the repo and regenerates any figure. The whole study cost $0 (free NIM API).</a:t>
+            </a:r>
+            <a:endParaRPr lang="en-US" sz="1350" dirty="0"/>
+          </a:p>
+          <a:p>
+            <a:pPr marL="203200" indent="-203200">
+              <a:spcAft>
+                <a:spcPts val="900"/>
+              </a:spcAft>
+              <a:buSzPct val="100000"/>
+              <a:buChar char="•"/>
+            </a:pPr>
+            <a:r>
+              <a:rPr lang="en-US" sz="1350" dirty="0">
+                <a:solidFill>
+                  <a:srgbClr val="2E2C32"/>
+                </a:solidFill>
+                <a:latin typeface="Manrope" pitchFamily="34" charset="0"/>
+                <a:ea typeface="Manrope" pitchFamily="34" charset="-122"/>
+                <a:cs typeface="Manrope" pitchFamily="34" charset="-120"/>
+              </a:rPr>
+              <a:t>DECISIONS.md logs every call we made and every one we changed.</a:t>
+            </a:r>
+            <a:endParaRPr lang="en-US" sz="1350" dirty="0"/>
+          </a:p>
+        </p:txBody>
+      </p:sp>
+    </p:spTree>
+  </p:cSld>
+  <p:clrMapOvr>
+    <a:masterClrMapping/>
+  </p:clrMapOvr>
+</p:sld>
+</file>
+
+<file path=ppt/slides/slide17.xml><?xml version="1.0" encoding="utf-8"?>
+<p:sld xmlns:a="http://schemas.openxmlformats.org/drawingml/2006/main" xmlns:r="http://schemas.openxmlformats.org/officeDocument/2006/relationships" xmlns:p="http://schemas.openxmlformats.org/presentationml/2006/main">
+  <p:cSld name="Slide 17">
+    <p:bg>
+      <p:bgPr>
+        <a:solidFill>
+          <a:srgbClr val="2E2C32"/>
+        </a:solidFill>
+      </p:bgPr>
+    </p:bg>
+    <p:spTree>
+      <p:nvGrpSpPr>
+        <p:cNvPr id="1" name=""/>
+        <p:cNvGrpSpPr/>
+        <p:nvPr/>
+      </p:nvGrpSpPr>
+      <p:grpSpPr>
+        <a:xfrm>
+          <a:off x="0" y="0"/>
+          <a:ext cx="0" cy="0"/>
+          <a:chOff x="0" y="0"/>
+          <a:chExt cx="0" cy="0"/>
+        </a:xfrm>
+      </p:grpSpPr>
+      <p:sp>
+        <p:nvSpPr>
+          <p:cNvPr id="2" name="Text 0"/>
+          <p:cNvSpPr/>
+          <p:nvPr/>
+        </p:nvSpPr>
+        <p:spPr>
+          <a:xfrm>
+            <a:off x="548640" y="548640"/>
+            <a:ext cx="8229600" cy="365760"/>
+          </a:xfrm>
+          <a:prstGeom prst="rect">
+            <a:avLst/>
+          </a:prstGeom>
+          <a:noFill/>
+          <a:ln/>
+        </p:spPr>
+        <p:txBody>
+          <a:bodyPr wrap="square" lIns="0" tIns="0" rIns="0" bIns="0" rtlCol="0" anchor="ctr"/>
+          <a:lstStyle/>
+          <a:p>
+            <a:pPr indent="0" marL="0">
+              <a:buNone/>
+            </a:pPr>
+            <a:r>
+              <a:rPr lang="en-US" sz="1200" b="1" spc="400" kern="0" dirty="0">
+                <a:solidFill>
+                  <a:srgbClr val="9378FF"/>
+                </a:solidFill>
+                <a:latin typeface="Syne" pitchFamily="34" charset="0"/>
+                <a:ea typeface="Syne" pitchFamily="34" charset="-122"/>
+                <a:cs typeface="Syne" pitchFamily="34" charset="-120"/>
+              </a:rPr>
+              <a:t>FIND ME</a:t>
+            </a:r>
+            <a:endParaRPr lang="en-US" sz="1200" dirty="0"/>
+          </a:p>
+        </p:txBody>
+      </p:sp>
+      <p:sp>
+        <p:nvSpPr>
+          <p:cNvPr id="3" name="Text 1"/>
+          <p:cNvSpPr/>
+          <p:nvPr/>
+        </p:nvSpPr>
+        <p:spPr>
+          <a:xfrm>
+            <a:off x="548640" y="914400"/>
+            <a:ext cx="8229600" cy="640080"/>
+          </a:xfrm>
+          <a:prstGeom prst="rect">
+            <a:avLst/>
+          </a:prstGeom>
+          <a:noFill/>
+          <a:ln/>
+        </p:spPr>
+        <p:txBody>
+          <a:bodyPr wrap="square" lIns="0" tIns="0" rIns="0" bIns="0" rtlCol="0" anchor="ctr"/>
+          <a:lstStyle/>
+          <a:p>
+            <a:pPr indent="0" marL="0">
+              <a:buNone/>
+            </a:pPr>
+            <a:r>
+              <a:rPr lang="en-US" sz="3000" b="1" dirty="0">
+                <a:solidFill>
+                  <a:srgbClr val="FFFFFF"/>
+                </a:solidFill>
+                <a:latin typeface="Syne" pitchFamily="34" charset="0"/>
+                <a:ea typeface="Syne" pitchFamily="34" charset="-122"/>
+                <a:cs typeface="Syne" pitchFamily="34" charset="-120"/>
+              </a:rPr>
+              <a:t>Clone it. Break it. Tell me I'm wrong.</a:t>
+            </a:r>
+            <a:endParaRPr lang="en-US" sz="3000" dirty="0"/>
+          </a:p>
+        </p:txBody>
+      </p:sp>
+      <p:pic>
+        <p:nvPicPr>
+          <p:cNvPr id="4" name="Image 0" descr="/Users/kanishk/Desktop/agent-harness/presentation/assets/qr/qr_repo.png">    </p:cNvPr>
+          <p:cNvPicPr>
+            <a:picLocks noChangeAspect="1"/>
+          </p:cNvPicPr>
+          <p:nvPr/>
+        </p:nvPicPr>
+        <p:blipFill>
+          <a:blip r:embed="rId1"/>
+          <a:stretch>
+            <a:fillRect/>
+          </a:stretch>
+        </p:blipFill>
+        <p:spPr>
+          <a:xfrm>
             <a:off x="868680" y="2103120"/>
             <a:ext cx="1143000" cy="1143000"/>
           </a:xfrm>
@@ -4121,7 +5519,7 @@
                 <a:ea typeface="Manrope" pitchFamily="34" charset="-122"/>
                 <a:cs typeface="Manrope" pitchFamily="34" charset="-120"/>
               </a:rPr>
-              <a:t>14</a:t>
+              <a:t>17</a:t>
             </a:r>
             <a:endParaRPr lang="en-US" sz="900" dirty="0"/>
           </a:p>
@@ -4365,7 +5763,7 @@
                 <a:ea typeface="Manrope" pitchFamily="34" charset="-122"/>
                 <a:cs typeface="Manrope" pitchFamily="34" charset="-120"/>
               </a:rPr>
-              <a:t>And the single most important thing it does is decide what to forget. Get that wrong and the agent drifts, repeats, and dies. Tonight: the code that gets it right, and every time it was wrong first.</a:t>
+              <a:t>And the single most important thing it does is decide what to forget. Get that wrong and the agent drifts, repeats, and dies. Tonight: the code that gets it right, and how the memory systems you already use actually perform.</a:t>
             </a:r>
             <a:endParaRPr lang="en-US" sz="1400" dirty="0"/>
           </a:p>
@@ -5739,7 +7137,7 @@
     <p:bg>
       <p:bgPr>
         <a:solidFill>
-          <a:srgbClr val="FAFAFE"/>
+          <a:srgbClr val="2E2C32"/>
         </a:solidFill>
       </p:bgPr>
     </p:bg>
@@ -5765,24 +7163,24 @@
         </p:nvSpPr>
         <p:spPr>
           <a:xfrm>
-            <a:off x="548640" y="365760"/>
-            <a:ext cx="8046720" cy="274320"/>
-          </a:xfrm>
-          <a:prstGeom prst="rect">
-            <a:avLst/>
-          </a:prstGeom>
-          <a:noFill/>
-          <a:ln/>
-        </p:spPr>
-        <p:txBody>
-          <a:bodyPr wrap="square" lIns="0" tIns="0" rIns="0" bIns="0" rtlCol="0" anchor="ctr"/>
-          <a:lstStyle/>
-          <a:p>
-            <a:pPr indent="0" marL="0">
-              <a:buNone/>
-            </a:pPr>
-            <a:r>
-              <a:rPr lang="en-US" sz="1100" b="1" spc="300" kern="0" dirty="0">
+            <a:off x="548640" y="1234440"/>
+            <a:ext cx="8229600" cy="365760"/>
+          </a:xfrm>
+          <a:prstGeom prst="rect">
+            <a:avLst/>
+          </a:prstGeom>
+          <a:noFill/>
+          <a:ln/>
+        </p:spPr>
+        <p:txBody>
+          <a:bodyPr wrap="square" lIns="0" tIns="0" rIns="0" bIns="0" rtlCol="0" anchor="ctr"/>
+          <a:lstStyle/>
+          <a:p>
+            <a:pPr indent="0" marL="0">
+              <a:buNone/>
+            </a:pPr>
+            <a:r>
+              <a:rPr lang="en-US" sz="1300" b="1" spc="400" kern="0" dirty="0">
                 <a:solidFill>
                   <a:srgbClr val="9378FF"/>
                 </a:solidFill>
@@ -5790,9 +7188,9 @@
                 <a:ea typeface="Syne" pitchFamily="34" charset="-122"/>
                 <a:cs typeface="Syne" pitchFamily="34" charset="-120"/>
               </a:rPr>
-              <a:t>WAR STORY</a:t>
-            </a:r>
-            <a:endParaRPr lang="en-US" sz="1100" dirty="0"/>
+              <a:t>LIVE</a:t>
+            </a:r>
+            <a:endParaRPr lang="en-US" sz="1300" dirty="0"/>
           </a:p>
         </p:txBody>
       </p:sp>
@@ -5804,34 +7202,34 @@
         </p:nvSpPr>
         <p:spPr>
           <a:xfrm>
-            <a:off x="548640" y="658368"/>
-            <a:ext cx="8046720" cy="457200"/>
-          </a:xfrm>
-          <a:prstGeom prst="rect">
-            <a:avLst/>
-          </a:prstGeom>
-          <a:noFill/>
-          <a:ln/>
-        </p:spPr>
-        <p:txBody>
-          <a:bodyPr wrap="square" lIns="0" tIns="0" rIns="0" bIns="0" rtlCol="0" anchor="ctr"/>
-          <a:lstStyle/>
-          <a:p>
-            <a:pPr indent="0" marL="0">
-              <a:buNone/>
-            </a:pPr>
-            <a:r>
-              <a:rPr lang="en-US" sz="2400" b="1" dirty="0">
-                <a:solidFill>
-                  <a:srgbClr val="2E2C32"/>
+            <a:off x="548640" y="1645920"/>
+            <a:ext cx="8229600" cy="1188720"/>
+          </a:xfrm>
+          <a:prstGeom prst="rect">
+            <a:avLst/>
+          </a:prstGeom>
+          <a:noFill/>
+          <a:ln/>
+        </p:spPr>
+        <p:txBody>
+          <a:bodyPr wrap="square" lIns="0" tIns="0" rIns="0" bIns="0" rtlCol="0" anchor="ctr"/>
+          <a:lstStyle/>
+          <a:p>
+            <a:pPr indent="0" marL="0">
+              <a:buNone/>
+            </a:pPr>
+            <a:r>
+              <a:rPr lang="en-US" sz="3200" b="1" dirty="0">
+                <a:solidFill>
+                  <a:srgbClr val="FFFFFF"/>
                 </a:solidFill>
                 <a:latin typeface="Syne" pitchFamily="34" charset="0"/>
                 <a:ea typeface="Syne" pitchFamily="34" charset="-122"/>
                 <a:cs typeface="Syne" pitchFamily="34" charset="-120"/>
               </a:rPr>
-              <a:t>The metric that almost fooled me</a:t>
-            </a:r>
-            <a:endParaRPr lang="en-US" sz="2400" dirty="0"/>
+              <a:t>Watch it grow, COMPACT, snap back, keep going.</a:t>
+            </a:r>
+            <a:endParaRPr lang="en-US" sz="3200" dirty="0"/>
           </a:p>
         </p:txBody>
       </p:sp>
@@ -5843,34 +7241,34 @@
         </p:nvSpPr>
         <p:spPr>
           <a:xfrm>
-            <a:off x="548640" y="1463040"/>
-            <a:ext cx="8046720" cy="914400"/>
-          </a:xfrm>
-          <a:prstGeom prst="rect">
-            <a:avLst/>
-          </a:prstGeom>
-          <a:noFill/>
-          <a:ln/>
-        </p:spPr>
-        <p:txBody>
-          <a:bodyPr wrap="square" lIns="0" tIns="0" rIns="0" bIns="0" rtlCol="0" anchor="ctr"/>
-          <a:lstStyle/>
-          <a:p>
-            <a:pPr indent="0" marL="0">
-              <a:buNone/>
-            </a:pPr>
-            <a:r>
-              <a:rPr lang="en-US" sz="4000" b="1" dirty="0">
+            <a:off x="548640" y="2971800"/>
+            <a:ext cx="8229600" cy="365760"/>
+          </a:xfrm>
+          <a:prstGeom prst="rect">
+            <a:avLst/>
+          </a:prstGeom>
+          <a:noFill/>
+          <a:ln/>
+        </p:spPr>
+        <p:txBody>
+          <a:bodyPr wrap="square" lIns="0" tIns="0" rIns="0" bIns="0" rtlCol="0" anchor="ctr"/>
+          <a:lstStyle/>
+          <a:p>
+            <a:pPr indent="0" marL="0">
+              <a:buNone/>
+            </a:pPr>
+            <a:r>
+              <a:rPr lang="en-US" sz="1500" dirty="0">
                 <a:solidFill>
                   <a:srgbClr val="9378FF"/>
                 </a:solidFill>
-                <a:latin typeface="Syne" pitchFamily="34" charset="0"/>
-                <a:ea typeface="Syne" pitchFamily="34" charset="-122"/>
-                <a:cs typeface="Syne" pitchFamily="34" charset="-120"/>
-              </a:rPr>
-              <a:t>0.21  →  0.62</a:t>
-            </a:r>
-            <a:endParaRPr lang="en-US" sz="4000" dirty="0"/>
+                <a:latin typeface="Courier New" pitchFamily="34" charset="0"/>
+                <a:ea typeface="Courier New" pitchFamily="34" charset="-122"/>
+                <a:cs typeface="Courier New" pitchFamily="34" charset="-120"/>
+              </a:rPr>
+              <a:t>python run.py     ·     cat run/notes.md</a:t>
+            </a:r>
+            <a:endParaRPr lang="en-US" sz="1500" dirty="0"/>
           </a:p>
         </p:txBody>
       </p:sp>
@@ -5882,105 +7280,71 @@
         </p:nvSpPr>
         <p:spPr>
           <a:xfrm>
-            <a:off x="548640" y="2606040"/>
-            <a:ext cx="8046720" cy="1097280"/>
-          </a:xfrm>
-          <a:prstGeom prst="rect">
-            <a:avLst/>
-          </a:prstGeom>
-          <a:noFill/>
-          <a:ln/>
-        </p:spPr>
-        <p:txBody>
-          <a:bodyPr wrap="square" lIns="0" tIns="0" rIns="0" bIns="0" rtlCol="0" anchor="ctr"/>
-          <a:lstStyle/>
-          <a:p>
-            <a:pPr indent="0" marL="0">
-              <a:buNone/>
-            </a:pPr>
-            <a:r>
-              <a:rPr lang="en-US" sz="1600" dirty="0">
-                <a:solidFill>
-                  <a:srgbClr val="2E2C32"/>
+            <a:off x="548640" y="3429000"/>
+            <a:ext cx="8229600" cy="365760"/>
+          </a:xfrm>
+          <a:prstGeom prst="rect">
+            <a:avLst/>
+          </a:prstGeom>
+          <a:noFill/>
+          <a:ln/>
+        </p:spPr>
+        <p:txBody>
+          <a:bodyPr wrap="square" lIns="0" tIns="0" rIns="0" bIns="0" rtlCol="0" anchor="ctr"/>
+          <a:lstStyle/>
+          <a:p>
+            <a:pPr indent="0" marL="0">
+              <a:buNone/>
+            </a:pPr>
+            <a:r>
+              <a:rPr lang="en-US" sz="1400" dirty="0">
+                <a:solidFill>
+                  <a:srgbClr val="CADCFC"/>
+                </a:solidFill>
+                <a:latin typeface="Courier New" pitchFamily="34" charset="0"/>
+                <a:ea typeface="Courier New" pitchFamily="34" charset="-122"/>
+                <a:cs typeface="Courier New" pitchFamily="34" charset="-120"/>
+              </a:rPr>
+              <a:t>python -m harness.compare "..."     # 7 policies, one needle, who keeps it</a:t>
+            </a:r>
+            <a:endParaRPr lang="en-US" sz="1400" dirty="0"/>
+          </a:p>
+        </p:txBody>
+      </p:sp>
+      <p:sp>
+        <p:nvSpPr>
+          <p:cNvPr id="6" name="Text 4"/>
+          <p:cNvSpPr/>
+          <p:nvPr/>
+        </p:nvSpPr>
+        <p:spPr>
+          <a:xfrm>
+            <a:off x="548640" y="3931920"/>
+            <a:ext cx="8229600" cy="365760"/>
+          </a:xfrm>
+          <a:prstGeom prst="rect">
+            <a:avLst/>
+          </a:prstGeom>
+          <a:noFill/>
+          <a:ln/>
+        </p:spPr>
+        <p:txBody>
+          <a:bodyPr wrap="square" lIns="0" tIns="0" rIns="0" bIns="0" rtlCol="0" anchor="ctr"/>
+          <a:lstStyle/>
+          <a:p>
+            <a:pPr indent="0" marL="0">
+              <a:buNone/>
+            </a:pPr>
+            <a:r>
+              <a:rPr lang="en-US" sz="1400" dirty="0">
+                <a:solidFill>
+                  <a:srgbClr val="7E7A8A"/>
                 </a:solidFill>
                 <a:latin typeface="Manrope" pitchFamily="34" charset="0"/>
                 <a:ea typeface="Manrope" pitchFamily="34" charset="-122"/>
                 <a:cs typeface="Manrope" pitchFamily="34" charset="-120"/>
               </a:rPr>
-              <a:t>Substring scoring made my best policy look like the worst. An LLM judge that credits paraphrase flipped it to best.</a:t>
-            </a:r>
-            <a:endParaRPr lang="en-US" sz="1600" dirty="0"/>
-          </a:p>
-        </p:txBody>
-      </p:sp>
-      <p:sp>
-        <p:nvSpPr>
-          <p:cNvPr id="6" name="Shape 4"/>
-          <p:cNvSpPr/>
-          <p:nvPr/>
-        </p:nvSpPr>
-        <p:spPr>
-          <a:xfrm>
-            <a:off x="548640" y="3886200"/>
-            <a:ext cx="91440" cy="457200"/>
-          </a:xfrm>
-          <a:prstGeom prst="rect">
-            <a:avLst/>
-          </a:prstGeom>
-          <a:solidFill>
-            <a:srgbClr val="9378FF"/>
-          </a:solidFill>
-          <a:ln/>
-        </p:spPr>
-      </p:sp>
-      <p:sp>
-        <p:nvSpPr>
-          <p:cNvPr id="7" name="Text 5"/>
-          <p:cNvSpPr/>
-          <p:nvPr/>
-        </p:nvSpPr>
-        <p:spPr>
-          <a:xfrm>
-            <a:off x="768096" y="3886200"/>
-            <a:ext cx="7863840" cy="457200"/>
-          </a:xfrm>
-          <a:prstGeom prst="rect">
-            <a:avLst/>
-          </a:prstGeom>
-          <a:noFill/>
-          <a:ln/>
-        </p:spPr>
-        <p:txBody>
-          <a:bodyPr wrap="square" lIns="0" tIns="0" rIns="0" bIns="0" rtlCol="0" anchor="ctr"/>
-          <a:lstStyle/>
-          <a:p>
-            <a:pPr indent="0" marL="0">
-              <a:buNone/>
-            </a:pPr>
-            <a:r>
-              <a:rPr lang="en-US" sz="1400" b="1" dirty="0">
-                <a:solidFill>
-                  <a:srgbClr val="7B5EF0"/>
-                </a:solidFill>
-                <a:latin typeface="Manrope" pitchFamily="34" charset="0"/>
-                <a:ea typeface="Manrope" pitchFamily="34" charset="-122"/>
-                <a:cs typeface="Manrope" pitchFamily="34" charset="-120"/>
-              </a:rPr>
-              <a:t>Lesson  </a:t>
-            </a:r>
-            <a:pPr indent="0" marL="0">
-              <a:buNone/>
-            </a:pPr>
-            <a:r>
-              <a:rPr lang="en-US" sz="1400" dirty="0">
-                <a:solidFill>
-                  <a:srgbClr val="655E74"/>
-                </a:solidFill>
-                <a:latin typeface="Manrope" pitchFamily="34" charset="0"/>
-                <a:ea typeface="Manrope" pitchFamily="34" charset="-122"/>
-                <a:cs typeface="Manrope" pitchFamily="34" charset="-120"/>
-              </a:rPr>
-              <a:t>Your eval can quietly invert your conclusion.</a:t>
+              <a:t>Offline. No key. The window forgets; the scratchpad does not.</a:t>
             </a:r>
             <a:endParaRPr lang="en-US" sz="1400" dirty="0"/>
           </a:p>
@@ -5988,7 +7352,7 @@
       </p:sp>
       <p:pic>
         <p:nvPicPr>
-          <p:cNvPr id="8" name="Image 0" descr="preencoded.png">    </p:cNvPr>
+          <p:cNvPr id="7" name="Image 0" descr="preencoded.png">    </p:cNvPr>
           <p:cNvPicPr>
             <a:picLocks noChangeAspect="1"/>
           </p:cNvPicPr>
@@ -6012,7 +7376,7 @@
       </p:pic>
       <p:sp>
         <p:nvSpPr>
-          <p:cNvPr id="9" name="Text 6"/>
+          <p:cNvPr id="8" name="Text 5"/>
           <p:cNvSpPr/>
           <p:nvPr/>
         </p:nvSpPr>
@@ -6037,7 +7401,7 @@
             <a:r>
               <a:rPr lang="en-US" sz="1100" b="1" dirty="0">
                 <a:solidFill>
-                  <a:srgbClr val="2E2C32"/>
+                  <a:srgbClr val="FFFFFF"/>
                 </a:solidFill>
                 <a:latin typeface="Syne" pitchFamily="34" charset="0"/>
                 <a:ea typeface="Syne" pitchFamily="34" charset="-122"/>
@@ -6065,7 +7429,7 @@
       </p:sp>
       <p:sp>
         <p:nvSpPr>
-          <p:cNvPr id="10" name="Text 7"/>
+          <p:cNvPr id="9" name="Text 6"/>
           <p:cNvSpPr/>
           <p:nvPr/>
         </p:nvSpPr>
@@ -6167,7 +7531,7 @@
                 <a:ea typeface="Syne" pitchFamily="34" charset="-122"/>
                 <a:cs typeface="Syne" pitchFamily="34" charset="-120"/>
               </a:rPr>
-              <a:t>WAR STORY</a:t>
+              <a:t>YOU ARE NOT ALONE</a:t>
             </a:r>
             <a:endParaRPr lang="en-US" sz="1100" dirty="0"/>
           </a:p>
@@ -6181,24 +7545,24 @@
         </p:nvSpPr>
         <p:spPr>
           <a:xfrm>
-            <a:off x="548640" y="658368"/>
-            <a:ext cx="8046720" cy="457200"/>
-          </a:xfrm>
-          <a:prstGeom prst="rect">
-            <a:avLst/>
-          </a:prstGeom>
-          <a:noFill/>
-          <a:ln/>
-        </p:spPr>
-        <p:txBody>
-          <a:bodyPr wrap="square" lIns="0" tIns="0" rIns="0" bIns="0" rtlCol="0" anchor="ctr"/>
-          <a:lstStyle/>
-          <a:p>
-            <a:pPr indent="0" marL="0">
-              <a:buNone/>
-            </a:pPr>
-            <a:r>
-              <a:rPr lang="en-US" sz="2400" b="1" dirty="0">
+            <a:off x="548640" y="640080"/>
+            <a:ext cx="8046720" cy="822960"/>
+          </a:xfrm>
+          <a:prstGeom prst="rect">
+            <a:avLst/>
+          </a:prstGeom>
+          <a:noFill/>
+          <a:ln/>
+        </p:spPr>
+        <p:txBody>
+          <a:bodyPr wrap="square" lIns="0" tIns="0" rIns="0" bIns="0" rtlCol="0" anchor="t"/>
+          <a:lstStyle/>
+          <a:p>
+            <a:pPr indent="0" marL="0">
+              <a:buNone/>
+            </a:pPr>
+            <a:r>
+              <a:rPr lang="en-US" sz="2500" b="1" dirty="0">
                 <a:solidFill>
                   <a:srgbClr val="2E2C32"/>
                 </a:solidFill>
@@ -6206,166 +7570,15 @@
                 <a:ea typeface="Syne" pitchFamily="34" charset="-122"/>
                 <a:cs typeface="Syne" pitchFamily="34" charset="-120"/>
               </a:rPr>
-              <a:t>The agent that froze at 0% CPU</a:t>
-            </a:r>
-            <a:endParaRPr lang="en-US" sz="2400" dirty="0"/>
-          </a:p>
-        </p:txBody>
-      </p:sp>
-      <p:sp>
-        <p:nvSpPr>
-          <p:cNvPr id="4" name="Text 2"/>
-          <p:cNvSpPr/>
-          <p:nvPr/>
-        </p:nvSpPr>
-        <p:spPr>
-          <a:xfrm>
-            <a:off x="548640" y="1463040"/>
-            <a:ext cx="8046720" cy="914400"/>
-          </a:xfrm>
-          <a:prstGeom prst="rect">
-            <a:avLst/>
-          </a:prstGeom>
-          <a:noFill/>
-          <a:ln/>
-        </p:spPr>
-        <p:txBody>
-          <a:bodyPr wrap="square" lIns="0" tIns="0" rIns="0" bIns="0" rtlCol="0" anchor="ctr"/>
-          <a:lstStyle/>
-          <a:p>
-            <a:pPr indent="0" marL="0">
-              <a:buNone/>
-            </a:pPr>
-            <a:r>
-              <a:rPr lang="en-US" sz="4000" b="1" dirty="0">
-                <a:solidFill>
-                  <a:srgbClr val="9378FF"/>
-                </a:solidFill>
-                <a:latin typeface="Syne" pitchFamily="34" charset="0"/>
-                <a:ea typeface="Syne" pitchFamily="34" charset="-122"/>
-                <a:cs typeface="Syne" pitchFamily="34" charset="-120"/>
-              </a:rPr>
-              <a:t>no error. just gone.</a:t>
-            </a:r>
-            <a:endParaRPr lang="en-US" sz="4000" dirty="0"/>
-          </a:p>
-        </p:txBody>
-      </p:sp>
-      <p:sp>
-        <p:nvSpPr>
-          <p:cNvPr id="5" name="Text 3"/>
-          <p:cNvSpPr/>
-          <p:nvPr/>
-        </p:nvSpPr>
-        <p:spPr>
-          <a:xfrm>
-            <a:off x="548640" y="2606040"/>
-            <a:ext cx="8046720" cy="1097280"/>
-          </a:xfrm>
-          <a:prstGeom prst="rect">
-            <a:avLst/>
-          </a:prstGeom>
-          <a:noFill/>
-          <a:ln/>
-        </p:spPr>
-        <p:txBody>
-          <a:bodyPr wrap="square" lIns="0" tIns="0" rIns="0" bIns="0" rtlCol="0" anchor="ctr"/>
-          <a:lstStyle/>
-          <a:p>
-            <a:pPr indent="0" marL="0">
-              <a:buNone/>
-            </a:pPr>
-            <a:r>
-              <a:rPr lang="en-US" sz="1600" dirty="0">
-                <a:solidFill>
-                  <a:srgbClr val="2E2C32"/>
-                </a:solidFill>
-                <a:latin typeface="Manrope" pitchFamily="34" charset="0"/>
-                <a:ea typeface="Manrope" pitchFamily="34" charset="-122"/>
-                <a:cs typeface="Manrope" pitchFamily="34" charset="-120"/>
-              </a:rPr>
-              <a:t>Runs hung forever, Python idle, past the library timeout. Fix: a hard wall-clock watchdog on a worker thread (nim.py).</a:t>
-            </a:r>
-            <a:endParaRPr lang="en-US" sz="1600" dirty="0"/>
-          </a:p>
-        </p:txBody>
-      </p:sp>
-      <p:sp>
-        <p:nvSpPr>
-          <p:cNvPr id="6" name="Shape 4"/>
-          <p:cNvSpPr/>
-          <p:nvPr/>
-        </p:nvSpPr>
-        <p:spPr>
-          <a:xfrm>
-            <a:off x="548640" y="3886200"/>
-            <a:ext cx="91440" cy="457200"/>
-          </a:xfrm>
-          <a:prstGeom prst="rect">
-            <a:avLst/>
-          </a:prstGeom>
-          <a:solidFill>
-            <a:srgbClr val="9378FF"/>
-          </a:solidFill>
-          <a:ln/>
-        </p:spPr>
-      </p:sp>
-      <p:sp>
-        <p:nvSpPr>
-          <p:cNvPr id="7" name="Text 5"/>
-          <p:cNvSpPr/>
-          <p:nvPr/>
-        </p:nvSpPr>
-        <p:spPr>
-          <a:xfrm>
-            <a:off x="768096" y="3886200"/>
-            <a:ext cx="7863840" cy="457200"/>
-          </a:xfrm>
-          <a:prstGeom prst="rect">
-            <a:avLst/>
-          </a:prstGeom>
-          <a:noFill/>
-          <a:ln/>
-        </p:spPr>
-        <p:txBody>
-          <a:bodyPr wrap="square" lIns="0" tIns="0" rIns="0" bIns="0" rtlCol="0" anchor="ctr"/>
-          <a:lstStyle/>
-          <a:p>
-            <a:pPr indent="0" marL="0">
-              <a:buNone/>
-            </a:pPr>
-            <a:r>
-              <a:rPr lang="en-US" sz="1400" b="1" dirty="0">
-                <a:solidFill>
-                  <a:srgbClr val="7B5EF0"/>
-                </a:solidFill>
-                <a:latin typeface="Manrope" pitchFamily="34" charset="0"/>
-                <a:ea typeface="Manrope" pitchFamily="34" charset="-122"/>
-                <a:cs typeface="Manrope" pitchFamily="34" charset="-120"/>
-              </a:rPr>
-              <a:t>Lesson  </a:t>
-            </a:r>
-            <a:pPr indent="0" marL="0">
-              <a:buNone/>
-            </a:pPr>
-            <a:r>
-              <a:rPr lang="en-US" sz="1400" dirty="0">
-                <a:solidFill>
-                  <a:srgbClr val="655E74"/>
-                </a:solidFill>
-                <a:latin typeface="Manrope" pitchFamily="34" charset="0"/>
-                <a:ea typeface="Manrope" pitchFamily="34" charset="-122"/>
-                <a:cs typeface="Manrope" pitchFamily="34" charset="-120"/>
-              </a:rPr>
-              <a:t>Do not trust a library's timeout.</a:t>
-            </a:r>
-            <a:endParaRPr lang="en-US" sz="1400" dirty="0"/>
+              <a:t>The famous memory systems are the same seam.</a:t>
+            </a:r>
+            <a:endParaRPr lang="en-US" sz="2500" dirty="0"/>
           </a:p>
         </p:txBody>
       </p:sp>
       <p:pic>
         <p:nvPicPr>
-          <p:cNvPr id="8" name="Image 0" descr="preencoded.png">    </p:cNvPr>
+          <p:cNvPr id="4" name="Image 0" descr="preencoded.png">    </p:cNvPr>
           <p:cNvPicPr>
             <a:picLocks noChangeAspect="1"/>
           </p:cNvPicPr>
@@ -6389,7 +7602,7 @@
       </p:pic>
       <p:sp>
         <p:nvSpPr>
-          <p:cNvPr id="9" name="Text 6"/>
+          <p:cNvPr id="5" name="Text 2"/>
           <p:cNvSpPr/>
           <p:nvPr/>
         </p:nvSpPr>
@@ -6442,7 +7655,7 @@
       </p:sp>
       <p:sp>
         <p:nvSpPr>
-          <p:cNvPr id="10" name="Text 7"/>
+          <p:cNvPr id="6" name="Text 3"/>
           <p:cNvSpPr/>
           <p:nvPr/>
         </p:nvSpPr>
@@ -6476,6 +7689,277 @@
               <a:t>6</a:t>
             </a:r>
             <a:endParaRPr lang="en-US" sz="900" dirty="0"/>
+          </a:p>
+        </p:txBody>
+      </p:sp>
+      <p:sp>
+        <p:nvSpPr>
+          <p:cNvPr id="7" name="Text 4"/>
+          <p:cNvSpPr/>
+          <p:nvPr/>
+        </p:nvSpPr>
+        <p:spPr>
+          <a:xfrm>
+            <a:off x="548640" y="1554480"/>
+            <a:ext cx="8046720" cy="2743200"/>
+          </a:xfrm>
+          <a:prstGeom prst="rect">
+            <a:avLst/>
+          </a:prstGeom>
+          <a:noFill/>
+          <a:ln/>
+        </p:spPr>
+        <p:txBody>
+          <a:bodyPr wrap="square" rtlCol="0" anchor="ctr"/>
+          <a:lstStyle/>
+          <a:p>
+            <a:pPr marL="203200" indent="-203200">
+              <a:spcAft>
+                <a:spcPts val="900"/>
+              </a:spcAft>
+              <a:buSzPct val="100000"/>
+              <a:buChar char="•"/>
+            </a:pPr>
+            <a:r>
+              <a:rPr lang="en-US" sz="1200" dirty="0">
+                <a:solidFill>
+                  <a:srgbClr val="655E74"/>
+                </a:solidFill>
+                <a:latin typeface="Manrope" pitchFamily="34" charset="0"/>
+                <a:ea typeface="Manrope" pitchFamily="34" charset="-122"/>
+                <a:cs typeface="Manrope" pitchFamily="34" charset="-120"/>
+              </a:rPr>
+              <a:t>LangChain  summary-buffer</a:t>
+            </a:r>
+            <a:endParaRPr lang="en-US" sz="1400" dirty="0"/>
+          </a:p>
+          <a:p>
+            <a:pPr marL="203200" indent="-203200">
+              <a:spcAft>
+                <a:spcPts val="900"/>
+              </a:spcAft>
+              <a:buSzPct val="100000"/>
+              <a:buChar char="•"/>
+            </a:pPr>
+            <a:r>
+              <a:rPr lang="en-US" sz="1400" dirty="0">
+                <a:solidFill>
+                  <a:srgbClr val="2E2C32"/>
+                </a:solidFill>
+                <a:latin typeface="Manrope" pitchFamily="34" charset="0"/>
+                <a:ea typeface="Manrope" pitchFamily="34" charset="-122"/>
+                <a:cs typeface="Manrope" pitchFamily="34" charset="-120"/>
+              </a:rPr>
+              <a:t>→ compact. A rolling summary. Literally my 15-line recency.</a:t>
+            </a:r>
+            <a:endParaRPr lang="en-US" sz="1400" dirty="0"/>
+          </a:p>
+          <a:p>
+            <a:pPr marL="203200" indent="-203200">
+              <a:spcAft>
+                <a:spcPts val="900"/>
+              </a:spcAft>
+              <a:buSzPct val="100000"/>
+              <a:buChar char="•"/>
+            </a:pPr>
+            <a:r>
+              <a:rPr lang="en-US" sz="1200" dirty="0">
+                <a:solidFill>
+                  <a:srgbClr val="655E74"/>
+                </a:solidFill>
+                <a:latin typeface="Manrope" pitchFamily="34" charset="0"/>
+                <a:ea typeface="Manrope" pitchFamily="34" charset="-122"/>
+                <a:cs typeface="Manrope" pitchFamily="34" charset="-120"/>
+              </a:rPr>
+              <a:t>Chroma</a:t>
+            </a:r>
+            <a:endParaRPr lang="en-US" sz="1400" dirty="0"/>
+          </a:p>
+          <a:p>
+            <a:pPr marL="203200" indent="-203200">
+              <a:spcAft>
+                <a:spcPts val="900"/>
+              </a:spcAft>
+              <a:buSzPct val="100000"/>
+              <a:buChar char="•"/>
+            </a:pPr>
+            <a:r>
+              <a:rPr lang="en-US" sz="1400" dirty="0">
+                <a:solidFill>
+                  <a:srgbClr val="2E2C32"/>
+                </a:solidFill>
+                <a:latin typeface="Manrope" pitchFamily="34" charset="0"/>
+                <a:ea typeface="Manrope" pitchFamily="34" charset="-122"/>
+                <a:cs typeface="Manrope" pitchFamily="34" charset="-120"/>
+              </a:rPr>
+              <a:t>→ externalize. A vector store behind the same add / retrieve.</a:t>
+            </a:r>
+            <a:endParaRPr lang="en-US" sz="1400" dirty="0"/>
+          </a:p>
+          <a:p>
+            <a:pPr marL="203200" indent="-203200">
+              <a:spcAft>
+                <a:spcPts val="900"/>
+              </a:spcAft>
+              <a:buSzPct val="100000"/>
+              <a:buChar char="•"/>
+            </a:pPr>
+            <a:r>
+              <a:rPr lang="en-US" sz="1200" dirty="0">
+                <a:solidFill>
+                  <a:srgbClr val="655E74"/>
+                </a:solidFill>
+                <a:latin typeface="Manrope" pitchFamily="34" charset="0"/>
+                <a:ea typeface="Manrope" pitchFamily="34" charset="-122"/>
+                <a:cs typeface="Manrope" pitchFamily="34" charset="-120"/>
+              </a:rPr>
+              <a:t>Mem0</a:t>
+            </a:r>
+            <a:endParaRPr lang="en-US" sz="1400" dirty="0"/>
+          </a:p>
+          <a:p>
+            <a:pPr marL="203200" indent="-203200">
+              <a:spcAft>
+                <a:spcPts val="900"/>
+              </a:spcAft>
+              <a:buSzPct val="100000"/>
+              <a:buChar char="•"/>
+            </a:pPr>
+            <a:r>
+              <a:rPr lang="en-US" sz="1400" dirty="0">
+                <a:solidFill>
+                  <a:srgbClr val="2E2C32"/>
+                </a:solidFill>
+                <a:latin typeface="Manrope" pitchFamily="34" charset="0"/>
+                <a:ea typeface="Manrope" pitchFamily="34" charset="-122"/>
+                <a:cs typeface="Manrope" pitchFamily="34" charset="-120"/>
+              </a:rPr>
+              <a:t>→ externalize, but an LLM extracts and dedupes facts first.</a:t>
+            </a:r>
+            <a:endParaRPr lang="en-US" sz="1400" dirty="0"/>
+          </a:p>
+          <a:p>
+            <a:pPr marL="203200" indent="-203200">
+              <a:spcAft>
+                <a:spcPts val="900"/>
+              </a:spcAft>
+              <a:buSzPct val="100000"/>
+              <a:buChar char="•"/>
+            </a:pPr>
+            <a:r>
+              <a:rPr lang="en-US" sz="1200" dirty="0">
+                <a:solidFill>
+                  <a:srgbClr val="655E74"/>
+                </a:solidFill>
+                <a:latin typeface="Manrope" pitchFamily="34" charset="0"/>
+                <a:ea typeface="Manrope" pitchFamily="34" charset="-122"/>
+                <a:cs typeface="Manrope" pitchFamily="34" charset="-120"/>
+              </a:rPr>
+              <a:t>MemGPT / Letta</a:t>
+            </a:r>
+            <a:endParaRPr lang="en-US" sz="1400" dirty="0"/>
+          </a:p>
+          <a:p>
+            <a:pPr marL="203200" indent="-203200">
+              <a:spcAft>
+                <a:spcPts val="900"/>
+              </a:spcAft>
+              <a:buSzPct val="100000"/>
+              <a:buChar char="•"/>
+            </a:pPr>
+            <a:r>
+              <a:rPr lang="en-US" sz="1400" dirty="0">
+                <a:solidFill>
+                  <a:srgbClr val="2E2C32"/>
+                </a:solidFill>
+                <a:latin typeface="Manrope" pitchFamily="34" charset="0"/>
+                <a:ea typeface="Manrope" pitchFamily="34" charset="-122"/>
+                <a:cs typeface="Manrope" pitchFamily="34" charset="-120"/>
+              </a:rPr>
+              <a:t>→ pin + externalize. Agent-managed core blocks + an archival DB.</a:t>
+            </a:r>
+            <a:endParaRPr lang="en-US" sz="1400" dirty="0"/>
+          </a:p>
+          <a:p>
+            <a:pPr marL="203200" indent="-203200">
+              <a:spcAft>
+                <a:spcPts val="900"/>
+              </a:spcAft>
+              <a:buSzPct val="100000"/>
+              <a:buChar char="•"/>
+            </a:pPr>
+            <a:r>
+              <a:rPr lang="en-US" sz="1200" dirty="0">
+                <a:solidFill>
+                  <a:srgbClr val="655E74"/>
+                </a:solidFill>
+                <a:latin typeface="Manrope" pitchFamily="34" charset="0"/>
+                <a:ea typeface="Manrope" pitchFamily="34" charset="-122"/>
+                <a:cs typeface="Manrope" pitchFamily="34" charset="-120"/>
+              </a:rPr>
+              <a:t>Anthropic multi-agent</a:t>
+            </a:r>
+            <a:endParaRPr lang="en-US" sz="1400" dirty="0"/>
+          </a:p>
+          <a:p>
+            <a:pPr marL="203200" indent="-203200">
+              <a:spcAft>
+                <a:spcPts val="900"/>
+              </a:spcAft>
+              <a:buSzPct val="100000"/>
+              <a:buChar char="•"/>
+            </a:pPr>
+            <a:r>
+              <a:rPr lang="en-US" sz="1400" dirty="0">
+                <a:solidFill>
+                  <a:srgbClr val="2E2C32"/>
+                </a:solidFill>
+                <a:latin typeface="Manrope" pitchFamily="34" charset="0"/>
+                <a:ea typeface="Manrope" pitchFamily="34" charset="-122"/>
+                <a:cs typeface="Manrope" pitchFamily="34" charset="-120"/>
+              </a:rPr>
+              <a:t>→ isolate. Sub-agents, each a fresh window.</a:t>
+            </a:r>
+            <a:endParaRPr lang="en-US" sz="1400" dirty="0"/>
+          </a:p>
+        </p:txBody>
+      </p:sp>
+      <p:sp>
+        <p:nvSpPr>
+          <p:cNvPr id="8" name="Text 5"/>
+          <p:cNvSpPr/>
+          <p:nvPr/>
+        </p:nvSpPr>
+        <p:spPr>
+          <a:xfrm>
+            <a:off x="548640" y="4434840"/>
+            <a:ext cx="8046720" cy="320040"/>
+          </a:xfrm>
+          <a:prstGeom prst="rect">
+            <a:avLst/>
+          </a:prstGeom>
+          <a:noFill/>
+          <a:ln/>
+        </p:spPr>
+        <p:txBody>
+          <a:bodyPr wrap="square" lIns="0" tIns="0" rIns="0" bIns="0" rtlCol="0" anchor="ctr"/>
+          <a:lstStyle/>
+          <a:p>
+            <a:pPr indent="0" marL="0">
+              <a:buNone/>
+            </a:pPr>
+            <a:r>
+              <a:rPr lang="en-US" sz="1250" i="1" dirty="0">
+                <a:solidFill>
+                  <a:srgbClr val="7B5EF0"/>
+                </a:solidFill>
+                <a:latin typeface="Manrope" pitchFamily="34" charset="0"/>
+                <a:ea typeface="Manrope" pitchFamily="34" charset="-122"/>
+                <a:cs typeface="Manrope" pitchFamily="34" charset="-120"/>
+              </a:rPr>
+              <a:t>All points on one map. So I wrapped each behind the same interface and benched it.</a:t>
+            </a:r>
+            <a:endParaRPr lang="en-US" sz="1250" dirty="0"/>
           </a:p>
         </p:txBody>
       </p:sp>
@@ -6544,7 +8028,7 @@
                 <a:ea typeface="Syne" pitchFamily="34" charset="-122"/>
                 <a:cs typeface="Syne" pitchFamily="34" charset="-120"/>
               </a:rPr>
-              <a:t>WAR STORY</a:t>
+              <a:t>AND I MEASURED THEM</a:t>
             </a:r>
             <a:endParaRPr lang="en-US" sz="1100" dirty="0"/>
           </a:p>
@@ -6558,17 +8042,17 @@
         </p:nvSpPr>
         <p:spPr>
           <a:xfrm>
-            <a:off x="548640" y="658368"/>
-            <a:ext cx="8046720" cy="457200"/>
-          </a:xfrm>
-          <a:prstGeom prst="rect">
-            <a:avLst/>
-          </a:prstGeom>
-          <a:noFill/>
-          <a:ln/>
-        </p:spPr>
-        <p:txBody>
-          <a:bodyPr wrap="square" lIns="0" tIns="0" rIns="0" bIns="0" rtlCol="0" anchor="ctr"/>
+            <a:off x="548640" y="640080"/>
+            <a:ext cx="8046720" cy="822960"/>
+          </a:xfrm>
+          <a:prstGeom prst="rect">
+            <a:avLst/>
+          </a:prstGeom>
+          <a:noFill/>
+          <a:ln/>
+        </p:spPr>
+        <p:txBody>
+          <a:bodyPr wrap="square" lIns="0" tIns="0" rIns="0" bIns="0" rtlCol="0" anchor="t"/>
           <a:lstStyle/>
           <a:p>
             <a:pPr indent="0" marL="0">
@@ -6583,166 +8067,15 @@
                 <a:ea typeface="Syne" pitchFamily="34" charset="-122"/>
                 <a:cs typeface="Syne" pitchFamily="34" charset="-120"/>
               </a:rPr>
-              <a:t>The reasoning model that wouldn't shut up</a:t>
+              <a:t>The defaults are not the right choice.</a:t>
             </a:r>
             <a:endParaRPr lang="en-US" sz="2400" dirty="0"/>
-          </a:p>
-        </p:txBody>
-      </p:sp>
-      <p:sp>
-        <p:nvSpPr>
-          <p:cNvPr id="4" name="Text 2"/>
-          <p:cNvSpPr/>
-          <p:nvPr/>
-        </p:nvSpPr>
-        <p:spPr>
-          <a:xfrm>
-            <a:off x="548640" y="1463040"/>
-            <a:ext cx="8046720" cy="914400"/>
-          </a:xfrm>
-          <a:prstGeom prst="rect">
-            <a:avLst/>
-          </a:prstGeom>
-          <a:noFill/>
-          <a:ln/>
-        </p:spPr>
-        <p:txBody>
-          <a:bodyPr wrap="square" lIns="0" tIns="0" rIns="0" bIns="0" rtlCol="0" anchor="ctr"/>
-          <a:lstStyle/>
-          <a:p>
-            <a:pPr indent="0" marL="0">
-              <a:buNone/>
-            </a:pPr>
-            <a:r>
-              <a:rPr lang="en-US" sz="4000" b="1" dirty="0">
-                <a:solidFill>
-                  <a:srgbClr val="9378FF"/>
-                </a:solidFill>
-                <a:latin typeface="Syne" pitchFamily="34" charset="0"/>
-                <a:ea typeface="Syne" pitchFamily="34" charset="-122"/>
-                <a:cs typeface="Syne" pitchFamily="34" charset="-120"/>
-              </a:rPr>
-              <a:t>2k–20k token 'summaries'</a:t>
-            </a:r>
-            <a:endParaRPr lang="en-US" sz="4000" dirty="0"/>
-          </a:p>
-        </p:txBody>
-      </p:sp>
-      <p:sp>
-        <p:nvSpPr>
-          <p:cNvPr id="5" name="Text 3"/>
-          <p:cNvSpPr/>
-          <p:nvPr/>
-        </p:nvSpPr>
-        <p:spPr>
-          <a:xfrm>
-            <a:off x="548640" y="2606040"/>
-            <a:ext cx="8046720" cy="1097280"/>
-          </a:xfrm>
-          <a:prstGeom prst="rect">
-            <a:avLst/>
-          </a:prstGeom>
-          <a:noFill/>
-          <a:ln/>
-        </p:spPr>
-        <p:txBody>
-          <a:bodyPr wrap="square" lIns="0" tIns="0" rIns="0" bIns="0" rtlCol="0" anchor="ctr"/>
-          <a:lstStyle/>
-          <a:p>
-            <a:pPr indent="0" marL="0">
-              <a:buNone/>
-            </a:pPr>
-            <a:r>
-              <a:rPr lang="en-US" sz="1600" dirty="0">
-                <a:solidFill>
-                  <a:srgbClr val="2E2C32"/>
-                </a:solidFill>
-                <a:latin typeface="Manrope" pitchFamily="34" charset="0"/>
-                <a:ea typeface="Manrope" pitchFamily="34" charset="-122"/>
-                <a:cs typeface="Manrope" pitchFamily="34" charset="-120"/>
-              </a:rPr>
-              <a:t>Asked to compress, it rambled; turning thinking off corrupted it. Fix: a split summarizer (fast model compacts, reasoning model answers).</a:t>
-            </a:r>
-            <a:endParaRPr lang="en-US" sz="1600" dirty="0"/>
-          </a:p>
-        </p:txBody>
-      </p:sp>
-      <p:sp>
-        <p:nvSpPr>
-          <p:cNvPr id="6" name="Shape 4"/>
-          <p:cNvSpPr/>
-          <p:nvPr/>
-        </p:nvSpPr>
-        <p:spPr>
-          <a:xfrm>
-            <a:off x="548640" y="3886200"/>
-            <a:ext cx="91440" cy="457200"/>
-          </a:xfrm>
-          <a:prstGeom prst="rect">
-            <a:avLst/>
-          </a:prstGeom>
-          <a:solidFill>
-            <a:srgbClr val="9378FF"/>
-          </a:solidFill>
-          <a:ln/>
-        </p:spPr>
-      </p:sp>
-      <p:sp>
-        <p:nvSpPr>
-          <p:cNvPr id="7" name="Text 5"/>
-          <p:cNvSpPr/>
-          <p:nvPr/>
-        </p:nvSpPr>
-        <p:spPr>
-          <a:xfrm>
-            <a:off x="768096" y="3886200"/>
-            <a:ext cx="7863840" cy="457200"/>
-          </a:xfrm>
-          <a:prstGeom prst="rect">
-            <a:avLst/>
-          </a:prstGeom>
-          <a:noFill/>
-          <a:ln/>
-        </p:spPr>
-        <p:txBody>
-          <a:bodyPr wrap="square" lIns="0" tIns="0" rIns="0" bIns="0" rtlCol="0" anchor="ctr"/>
-          <a:lstStyle/>
-          <a:p>
-            <a:pPr indent="0" marL="0">
-              <a:buNone/>
-            </a:pPr>
-            <a:r>
-              <a:rPr lang="en-US" sz="1400" b="1" dirty="0">
-                <a:solidFill>
-                  <a:srgbClr val="7B5EF0"/>
-                </a:solidFill>
-                <a:latin typeface="Manrope" pitchFamily="34" charset="0"/>
-                <a:ea typeface="Manrope" pitchFamily="34" charset="-122"/>
-                <a:cs typeface="Manrope" pitchFamily="34" charset="-120"/>
-              </a:rPr>
-              <a:t>Lesson  </a:t>
-            </a:r>
-            <a:pPr indent="0" marL="0">
-              <a:buNone/>
-            </a:pPr>
-            <a:r>
-              <a:rPr lang="en-US" sz="1400" dirty="0">
-                <a:solidFill>
-                  <a:srgbClr val="655E74"/>
-                </a:solidFill>
-                <a:latin typeface="Manrope" pitchFamily="34" charset="0"/>
-                <a:ea typeface="Manrope" pitchFamily="34" charset="-122"/>
-                <a:cs typeface="Manrope" pitchFamily="34" charset="-120"/>
-              </a:rPr>
-              <a:t>Reasoning models are bad compactors.</a:t>
-            </a:r>
-            <a:endParaRPr lang="en-US" sz="1400" dirty="0"/>
           </a:p>
         </p:txBody>
       </p:sp>
       <p:pic>
         <p:nvPicPr>
-          <p:cNvPr id="8" name="Image 0" descr="preencoded.png">    </p:cNvPr>
+          <p:cNvPr id="4" name="Image 0" descr="preencoded.png">    </p:cNvPr>
           <p:cNvPicPr>
             <a:picLocks noChangeAspect="1"/>
           </p:cNvPicPr>
@@ -6766,7 +8099,7 @@
       </p:pic>
       <p:sp>
         <p:nvSpPr>
-          <p:cNvPr id="9" name="Text 6"/>
+          <p:cNvPr id="5" name="Text 2"/>
           <p:cNvSpPr/>
           <p:nvPr/>
         </p:nvSpPr>
@@ -6819,7 +8152,7 @@
       </p:sp>
       <p:sp>
         <p:nvSpPr>
-          <p:cNvPr id="10" name="Text 7"/>
+          <p:cNvPr id="6" name="Text 3"/>
           <p:cNvSpPr/>
           <p:nvPr/>
         </p:nvSpPr>
@@ -6853,6 +8186,547 @@
               <a:t>7</a:t>
             </a:r>
             <a:endParaRPr lang="en-US" sz="900" dirty="0"/>
+          </a:p>
+        </p:txBody>
+      </p:sp>
+      <p:sp>
+        <p:nvSpPr>
+          <p:cNvPr id="7" name="Shape 4"/>
+          <p:cNvSpPr/>
+          <p:nvPr/>
+        </p:nvSpPr>
+        <p:spPr>
+          <a:xfrm>
+            <a:off x="640080" y="1508760"/>
+            <a:ext cx="7863840" cy="841248"/>
+          </a:xfrm>
+          <a:prstGeom prst="roundRect">
+            <a:avLst>
+              <a:gd name="adj" fmla="val 6522"/>
+            </a:avLst>
+          </a:prstGeom>
+          <a:solidFill>
+            <a:srgbClr val="F4F2F8"/>
+          </a:solidFill>
+          <a:ln w="12700">
+            <a:solidFill>
+              <a:srgbClr val="D4C9FF"/>
+            </a:solidFill>
+            <a:prstDash val="solid"/>
+          </a:ln>
+        </p:spPr>
+      </p:sp>
+      <p:sp>
+        <p:nvSpPr>
+          <p:cNvPr id="8" name="Text 5"/>
+          <p:cNvSpPr/>
+          <p:nvPr/>
+        </p:nvSpPr>
+        <p:spPr>
+          <a:xfrm>
+            <a:off x="822960" y="1563624"/>
+            <a:ext cx="3657600" cy="731520"/>
+          </a:xfrm>
+          <a:prstGeom prst="rect">
+            <a:avLst/>
+          </a:prstGeom>
+          <a:noFill/>
+          <a:ln/>
+        </p:spPr>
+        <p:txBody>
+          <a:bodyPr wrap="square" lIns="0" tIns="0" rIns="0" bIns="0" rtlCol="0" anchor="ctr"/>
+          <a:lstStyle/>
+          <a:p>
+            <a:pPr indent="0" marL="0">
+              <a:buNone/>
+            </a:pPr>
+            <a:r>
+              <a:rPr lang="en-US" sz="1500" b="1" dirty="0">
+                <a:solidFill>
+                  <a:srgbClr val="2E2C32"/>
+                </a:solidFill>
+                <a:latin typeface="Manrope" pitchFamily="34" charset="0"/>
+                <a:ea typeface="Manrope" pitchFamily="34" charset="-122"/>
+                <a:cs typeface="Manrope" pitchFamily="34" charset="-120"/>
+              </a:rPr>
+              <a:t>our 15-line recency  </a:t>
+            </a:r>
+            <a:pPr indent="0" marL="0">
+              <a:buNone/>
+            </a:pPr>
+            <a:r>
+              <a:rPr lang="en-US" sz="1700" b="1" dirty="0">
+                <a:solidFill>
+                  <a:srgbClr val="2E8B57"/>
+                </a:solidFill>
+                <a:latin typeface="Manrope" pitchFamily="34" charset="0"/>
+                <a:ea typeface="Manrope" pitchFamily="34" charset="-122"/>
+                <a:cs typeface="Manrope" pitchFamily="34" charset="-120"/>
+              </a:rPr>
+              <a:t>0.45</a:t>
+            </a:r>
+            <a:endParaRPr lang="en-US" sz="1500" dirty="0"/>
+          </a:p>
+        </p:txBody>
+      </p:sp>
+      <p:sp>
+        <p:nvSpPr>
+          <p:cNvPr id="9" name="Text 6"/>
+          <p:cNvSpPr/>
+          <p:nvPr/>
+        </p:nvSpPr>
+        <p:spPr>
+          <a:xfrm>
+            <a:off x="4206240" y="1508760"/>
+            <a:ext cx="457200" cy="841248"/>
+          </a:xfrm>
+          <a:prstGeom prst="rect">
+            <a:avLst/>
+          </a:prstGeom>
+          <a:noFill/>
+          <a:ln/>
+        </p:spPr>
+        <p:txBody>
+          <a:bodyPr wrap="square" lIns="0" tIns="0" rIns="0" bIns="0" rtlCol="0" anchor="ctr"/>
+          <a:lstStyle/>
+          <a:p>
+            <a:pPr algn="ctr" indent="0" marL="0">
+              <a:buNone/>
+            </a:pPr>
+            <a:r>
+              <a:rPr lang="en-US" sz="1200" i="1" dirty="0">
+                <a:solidFill>
+                  <a:srgbClr val="7E7A8A"/>
+                </a:solidFill>
+                <a:latin typeface="Syne" pitchFamily="34" charset="0"/>
+                <a:ea typeface="Syne" pitchFamily="34" charset="-122"/>
+                <a:cs typeface="Syne" pitchFamily="34" charset="-120"/>
+              </a:rPr>
+              <a:t>vs</a:t>
+            </a:r>
+            <a:endParaRPr lang="en-US" sz="1200" dirty="0"/>
+          </a:p>
+        </p:txBody>
+      </p:sp>
+      <p:sp>
+        <p:nvSpPr>
+          <p:cNvPr id="10" name="Text 7"/>
+          <p:cNvSpPr/>
+          <p:nvPr/>
+        </p:nvSpPr>
+        <p:spPr>
+          <a:xfrm>
+            <a:off x="4663440" y="1563624"/>
+            <a:ext cx="3657600" cy="731520"/>
+          </a:xfrm>
+          <a:prstGeom prst="rect">
+            <a:avLst/>
+          </a:prstGeom>
+          <a:noFill/>
+          <a:ln/>
+        </p:spPr>
+        <p:txBody>
+          <a:bodyPr wrap="square" lIns="0" tIns="0" rIns="0" bIns="0" rtlCol="0" anchor="ctr"/>
+          <a:lstStyle/>
+          <a:p>
+            <a:pPr indent="0" marL="0">
+              <a:buNone/>
+            </a:pPr>
+            <a:r>
+              <a:rPr lang="en-US" sz="1400" dirty="0">
+                <a:solidFill>
+                  <a:srgbClr val="655E74"/>
+                </a:solidFill>
+                <a:latin typeface="Manrope" pitchFamily="34" charset="0"/>
+                <a:ea typeface="Manrope" pitchFamily="34" charset="-122"/>
+                <a:cs typeface="Manrope" pitchFamily="34" charset="-120"/>
+              </a:rPr>
+              <a:t>LangChain summary-buffer  </a:t>
+            </a:r>
+            <a:pPr indent="0" marL="0">
+              <a:buNone/>
+            </a:pPr>
+            <a:r>
+              <a:rPr lang="en-US" sz="1600" b="1" dirty="0">
+                <a:solidFill>
+                  <a:srgbClr val="A32D2D"/>
+                </a:solidFill>
+                <a:latin typeface="Manrope" pitchFamily="34" charset="0"/>
+                <a:ea typeface="Manrope" pitchFamily="34" charset="-122"/>
+                <a:cs typeface="Manrope" pitchFamily="34" charset="-120"/>
+              </a:rPr>
+              <a:t>0.35</a:t>
+            </a:r>
+            <a:endParaRPr lang="en-US" sz="1400" dirty="0"/>
+          </a:p>
+        </p:txBody>
+      </p:sp>
+      <p:sp>
+        <p:nvSpPr>
+          <p:cNvPr id="11" name="Text 8"/>
+          <p:cNvSpPr/>
+          <p:nvPr/>
+        </p:nvSpPr>
+        <p:spPr>
+          <a:xfrm>
+            <a:off x="822960" y="1965960"/>
+            <a:ext cx="7498080" cy="329184"/>
+          </a:xfrm>
+          <a:prstGeom prst="rect">
+            <a:avLst/>
+          </a:prstGeom>
+          <a:noFill/>
+          <a:ln/>
+        </p:spPr>
+        <p:txBody>
+          <a:bodyPr wrap="square" lIns="0" tIns="0" rIns="0" bIns="0" rtlCol="0" anchor="ctr"/>
+          <a:lstStyle/>
+          <a:p>
+            <a:pPr indent="0" marL="0">
+              <a:buNone/>
+            </a:pPr>
+            <a:r>
+              <a:rPr lang="en-US" sz="1150" i="1" dirty="0">
+                <a:solidFill>
+                  <a:srgbClr val="7B5EF0"/>
+                </a:solidFill>
+                <a:latin typeface="Manrope" pitchFamily="34" charset="0"/>
+                <a:ea typeface="Manrope" pitchFamily="34" charset="-122"/>
+                <a:cs typeface="Manrope" pitchFamily="34" charset="-120"/>
+              </a:rPr>
+              <a:t>The framework default bought a dependency, not accuracy — and cost more tokens.</a:t>
+            </a:r>
+            <a:endParaRPr lang="en-US" sz="1150" dirty="0"/>
+          </a:p>
+        </p:txBody>
+      </p:sp>
+      <p:sp>
+        <p:nvSpPr>
+          <p:cNvPr id="12" name="Shape 9"/>
+          <p:cNvSpPr/>
+          <p:nvPr/>
+        </p:nvSpPr>
+        <p:spPr>
+          <a:xfrm>
+            <a:off x="640080" y="2514600"/>
+            <a:ext cx="7863840" cy="841248"/>
+          </a:xfrm>
+          <a:prstGeom prst="roundRect">
+            <a:avLst>
+              <a:gd name="adj" fmla="val 6522"/>
+            </a:avLst>
+          </a:prstGeom>
+          <a:solidFill>
+            <a:srgbClr val="F4F2F8"/>
+          </a:solidFill>
+          <a:ln w="12700">
+            <a:solidFill>
+              <a:srgbClr val="D4C9FF"/>
+            </a:solidFill>
+            <a:prstDash val="solid"/>
+          </a:ln>
+        </p:spPr>
+      </p:sp>
+      <p:sp>
+        <p:nvSpPr>
+          <p:cNvPr id="13" name="Text 10"/>
+          <p:cNvSpPr/>
+          <p:nvPr/>
+        </p:nvSpPr>
+        <p:spPr>
+          <a:xfrm>
+            <a:off x="822960" y="2569464"/>
+            <a:ext cx="3657600" cy="731520"/>
+          </a:xfrm>
+          <a:prstGeom prst="rect">
+            <a:avLst/>
+          </a:prstGeom>
+          <a:noFill/>
+          <a:ln/>
+        </p:spPr>
+        <p:txBody>
+          <a:bodyPr wrap="square" lIns="0" tIns="0" rIns="0" bIns="0" rtlCol="0" anchor="ctr"/>
+          <a:lstStyle/>
+          <a:p>
+            <a:pPr indent="0" marL="0">
+              <a:buNone/>
+            </a:pPr>
+            <a:r>
+              <a:rPr lang="en-US" sz="1500" b="1" dirty="0">
+                <a:solidFill>
+                  <a:srgbClr val="2E2C32"/>
+                </a:solidFill>
+                <a:latin typeface="Manrope" pitchFamily="34" charset="0"/>
+                <a:ea typeface="Manrope" pitchFamily="34" charset="-122"/>
+                <a:cs typeface="Manrope" pitchFamily="34" charset="-120"/>
+              </a:rPr>
+              <a:t>nv-embedqa store  </a:t>
+            </a:r>
+            <a:pPr indent="0" marL="0">
+              <a:buNone/>
+            </a:pPr>
+            <a:r>
+              <a:rPr lang="en-US" sz="1700" b="1" dirty="0">
+                <a:solidFill>
+                  <a:srgbClr val="2E8B57"/>
+                </a:solidFill>
+                <a:latin typeface="Manrope" pitchFamily="34" charset="0"/>
+                <a:ea typeface="Manrope" pitchFamily="34" charset="-122"/>
+                <a:cs typeface="Manrope" pitchFamily="34" charset="-120"/>
+              </a:rPr>
+              <a:t>0.50</a:t>
+            </a:r>
+            <a:endParaRPr lang="en-US" sz="1500" dirty="0"/>
+          </a:p>
+        </p:txBody>
+      </p:sp>
+      <p:sp>
+        <p:nvSpPr>
+          <p:cNvPr id="14" name="Text 11"/>
+          <p:cNvSpPr/>
+          <p:nvPr/>
+        </p:nvSpPr>
+        <p:spPr>
+          <a:xfrm>
+            <a:off x="4206240" y="2514600"/>
+            <a:ext cx="457200" cy="841248"/>
+          </a:xfrm>
+          <a:prstGeom prst="rect">
+            <a:avLst/>
+          </a:prstGeom>
+          <a:noFill/>
+          <a:ln/>
+        </p:spPr>
+        <p:txBody>
+          <a:bodyPr wrap="square" lIns="0" tIns="0" rIns="0" bIns="0" rtlCol="0" anchor="ctr"/>
+          <a:lstStyle/>
+          <a:p>
+            <a:pPr algn="ctr" indent="0" marL="0">
+              <a:buNone/>
+            </a:pPr>
+            <a:r>
+              <a:rPr lang="en-US" sz="1200" i="1" dirty="0">
+                <a:solidFill>
+                  <a:srgbClr val="7E7A8A"/>
+                </a:solidFill>
+                <a:latin typeface="Syne" pitchFamily="34" charset="0"/>
+                <a:ea typeface="Syne" pitchFamily="34" charset="-122"/>
+                <a:cs typeface="Syne" pitchFamily="34" charset="-120"/>
+              </a:rPr>
+              <a:t>vs</a:t>
+            </a:r>
+            <a:endParaRPr lang="en-US" sz="1200" dirty="0"/>
+          </a:p>
+        </p:txBody>
+      </p:sp>
+      <p:sp>
+        <p:nvSpPr>
+          <p:cNvPr id="15" name="Text 12"/>
+          <p:cNvSpPr/>
+          <p:nvPr/>
+        </p:nvSpPr>
+        <p:spPr>
+          <a:xfrm>
+            <a:off x="4663440" y="2569464"/>
+            <a:ext cx="3657600" cy="731520"/>
+          </a:xfrm>
+          <a:prstGeom prst="rect">
+            <a:avLst/>
+          </a:prstGeom>
+          <a:noFill/>
+          <a:ln/>
+        </p:spPr>
+        <p:txBody>
+          <a:bodyPr wrap="square" lIns="0" tIns="0" rIns="0" bIns="0" rtlCol="0" anchor="ctr"/>
+          <a:lstStyle/>
+          <a:p>
+            <a:pPr indent="0" marL="0">
+              <a:buNone/>
+            </a:pPr>
+            <a:r>
+              <a:rPr lang="en-US" sz="1400" dirty="0">
+                <a:solidFill>
+                  <a:srgbClr val="655E74"/>
+                </a:solidFill>
+                <a:latin typeface="Manrope" pitchFamily="34" charset="0"/>
+                <a:ea typeface="Manrope" pitchFamily="34" charset="-122"/>
+                <a:cs typeface="Manrope" pitchFamily="34" charset="-120"/>
+              </a:rPr>
+              <a:t>MiniLM (general, local)  </a:t>
+            </a:r>
+            <a:pPr indent="0" marL="0">
+              <a:buNone/>
+            </a:pPr>
+            <a:r>
+              <a:rPr lang="en-US" sz="1600" b="1" dirty="0">
+                <a:solidFill>
+                  <a:srgbClr val="A32D2D"/>
+                </a:solidFill>
+                <a:latin typeface="Manrope" pitchFamily="34" charset="0"/>
+                <a:ea typeface="Manrope" pitchFamily="34" charset="-122"/>
+                <a:cs typeface="Manrope" pitchFamily="34" charset="-120"/>
+              </a:rPr>
+              <a:t>0.35</a:t>
+            </a:r>
+            <a:endParaRPr lang="en-US" sz="1400" dirty="0"/>
+          </a:p>
+        </p:txBody>
+      </p:sp>
+      <p:sp>
+        <p:nvSpPr>
+          <p:cNvPr id="16" name="Text 13"/>
+          <p:cNvSpPr/>
+          <p:nvPr/>
+        </p:nvSpPr>
+        <p:spPr>
+          <a:xfrm>
+            <a:off x="822960" y="2971800"/>
+            <a:ext cx="7498080" cy="329184"/>
+          </a:xfrm>
+          <a:prstGeom prst="rect">
+            <a:avLst/>
+          </a:prstGeom>
+          <a:noFill/>
+          <a:ln/>
+        </p:spPr>
+        <p:txBody>
+          <a:bodyPr wrap="square" lIns="0" tIns="0" rIns="0" bIns="0" rtlCol="0" anchor="ctr"/>
+          <a:lstStyle/>
+          <a:p>
+            <a:pPr indent="0" marL="0">
+              <a:buNone/>
+            </a:pPr>
+            <a:r>
+              <a:rPr lang="en-US" sz="1150" i="1" dirty="0">
+                <a:solidFill>
+                  <a:srgbClr val="7B5EF0"/>
+                </a:solidFill>
+                <a:latin typeface="Manrope" pitchFamily="34" charset="0"/>
+                <a:ea typeface="Manrope" pitchFamily="34" charset="-122"/>
+                <a:cs typeface="Manrope" pitchFamily="34" charset="-120"/>
+              </a:rPr>
+              <a:t>Same policy, swap only the embedder: the embedding model alone is +0.15.</a:t>
+            </a:r>
+            <a:endParaRPr lang="en-US" sz="1150" dirty="0"/>
+          </a:p>
+        </p:txBody>
+      </p:sp>
+      <p:sp>
+        <p:nvSpPr>
+          <p:cNvPr id="17" name="Shape 14"/>
+          <p:cNvSpPr/>
+          <p:nvPr/>
+        </p:nvSpPr>
+        <p:spPr>
+          <a:xfrm>
+            <a:off x="640080" y="3520440"/>
+            <a:ext cx="7863840" cy="841248"/>
+          </a:xfrm>
+          <a:prstGeom prst="roundRect">
+            <a:avLst>
+              <a:gd name="adj" fmla="val 6522"/>
+            </a:avLst>
+          </a:prstGeom>
+          <a:solidFill>
+            <a:srgbClr val="F4F2F8"/>
+          </a:solidFill>
+          <a:ln w="12700">
+            <a:solidFill>
+              <a:srgbClr val="D4C9FF"/>
+            </a:solidFill>
+            <a:prstDash val="solid"/>
+          </a:ln>
+        </p:spPr>
+      </p:sp>
+      <p:sp>
+        <p:nvSpPr>
+          <p:cNvPr id="18" name="Text 15"/>
+          <p:cNvSpPr/>
+          <p:nvPr/>
+        </p:nvSpPr>
+        <p:spPr>
+          <a:xfrm>
+            <a:off x="822960" y="3575304"/>
+            <a:ext cx="7498080" cy="457200"/>
+          </a:xfrm>
+          <a:prstGeom prst="rect">
+            <a:avLst/>
+          </a:prstGeom>
+          <a:noFill/>
+          <a:ln/>
+        </p:spPr>
+        <p:txBody>
+          <a:bodyPr wrap="square" lIns="0" tIns="0" rIns="0" bIns="0" rtlCol="0" anchor="ctr"/>
+          <a:lstStyle/>
+          <a:p>
+            <a:pPr indent="0" marL="0">
+              <a:buNone/>
+            </a:pPr>
+            <a:r>
+              <a:rPr lang="en-US" sz="1500" b="1" dirty="0">
+                <a:solidFill>
+                  <a:srgbClr val="2E2C32"/>
+                </a:solidFill>
+                <a:latin typeface="Manrope" pitchFamily="34" charset="0"/>
+                <a:ea typeface="Manrope" pitchFamily="34" charset="-122"/>
+                <a:cs typeface="Manrope" pitchFamily="34" charset="-120"/>
+              </a:rPr>
+              <a:t>Mem0  </a:t>
+            </a:r>
+            <a:pPr indent="0" marL="0">
+              <a:buNone/>
+            </a:pPr>
+            <a:r>
+              <a:rPr lang="en-US" sz="1400" dirty="0">
+                <a:solidFill>
+                  <a:srgbClr val="655E74"/>
+                </a:solidFill>
+                <a:latin typeface="Manrope" pitchFamily="34" charset="0"/>
+                <a:ea typeface="Manrope" pitchFamily="34" charset="-122"/>
+                <a:cs typeface="Manrope" pitchFamily="34" charset="-120"/>
+              </a:rPr>
+              <a:t>distills raw text → deduped facts</a:t>
+            </a:r>
+            <a:endParaRPr lang="en-US" sz="1500" dirty="0"/>
+          </a:p>
+        </p:txBody>
+      </p:sp>
+      <p:sp>
+        <p:nvSpPr>
+          <p:cNvPr id="19" name="Text 16"/>
+          <p:cNvSpPr/>
+          <p:nvPr/>
+        </p:nvSpPr>
+        <p:spPr>
+          <a:xfrm>
+            <a:off x="822960" y="3977640"/>
+            <a:ext cx="7498080" cy="329184"/>
+          </a:xfrm>
+          <a:prstGeom prst="rect">
+            <a:avLst/>
+          </a:prstGeom>
+          <a:noFill/>
+          <a:ln/>
+        </p:spPr>
+        <p:txBody>
+          <a:bodyPr wrap="square" lIns="0" tIns="0" rIns="0" bIns="0" rtlCol="0" anchor="ctr"/>
+          <a:lstStyle/>
+          <a:p>
+            <a:pPr indent="0" marL="0">
+              <a:buNone/>
+            </a:pPr>
+            <a:r>
+              <a:rPr lang="en-US" sz="1150" i="1" dirty="0">
+                <a:solidFill>
+                  <a:srgbClr val="7B5EF0"/>
+                </a:solidFill>
+                <a:latin typeface="Manrope" pitchFamily="34" charset="0"/>
+                <a:ea typeface="Manrope" pitchFamily="34" charset="-122"/>
+                <a:cs typeface="Manrope" pitchFamily="34" charset="-120"/>
+              </a:rPr>
+              <a:t>Trailed storing the raw chunks, and cost an LLM call on every write. Compression lost the needle.</a:t>
+            </a:r>
+            <a:endParaRPr lang="en-US" sz="1150" dirty="0"/>
           </a:p>
         </p:txBody>
       </p:sp>
@@ -6960,7 +8834,7 @@
                 <a:ea typeface="Syne" pitchFamily="34" charset="-122"/>
                 <a:cs typeface="Syne" pitchFamily="34" charset="-120"/>
               </a:rPr>
-              <a:t>The confound I caught the day before</a:t>
+              <a:t>The metric that almost fooled me</a:t>
             </a:r>
             <a:endParaRPr lang="en-US" sz="2400" dirty="0"/>
           </a:p>
@@ -6999,7 +8873,7 @@
                 <a:ea typeface="Syne" pitchFamily="34" charset="-122"/>
                 <a:cs typeface="Syne" pitchFamily="34" charset="-120"/>
               </a:rPr>
-              <a:t>0.67  →  0.53</a:t>
+              <a:t>0.21  →  0.62</a:t>
             </a:r>
             <a:endParaRPr lang="en-US" sz="4000" dirty="0"/>
           </a:p>
@@ -7038,7 +8912,7 @@
                 <a:ea typeface="Manrope" pitchFamily="34" charset="-122"/>
                 <a:cs typeface="Manrope" pitchFamily="34" charset="-120"/>
               </a:rPr>
-              <a:t>My 70B headline win shrank once I held the summarizer constant. The win was partly the summarizer, not the answer model.</a:t>
+              <a:t>Substring scoring made my best policy look like the worst. An LLM judge that credits paraphrase flipped it to best.</a:t>
             </a:r>
             <a:endParaRPr lang="en-US" sz="1600" dirty="0"/>
           </a:p>
@@ -7111,7 +8985,7 @@
                 <a:ea typeface="Manrope" pitchFamily="34" charset="-122"/>
                 <a:cs typeface="Manrope" pitchFamily="34" charset="-120"/>
               </a:rPr>
-              <a:t>Isolate your variable, even when it costs the headline.</a:t>
+              <a:t>Your eval can quietly invert your conclusion.</a:t>
             </a:r>
             <a:endParaRPr lang="en-US" sz="1400" dirty="0"/>
           </a:p>
@@ -7247,7 +9121,7 @@
     <p:bg>
       <p:bgPr>
         <a:solidFill>
-          <a:srgbClr val="2E2C32"/>
+          <a:srgbClr val="FAFAFE"/>
         </a:solidFill>
       </p:bgPr>
     </p:bg>
@@ -7273,24 +9147,24 @@
         </p:nvSpPr>
         <p:spPr>
           <a:xfrm>
-            <a:off x="548640" y="1325880"/>
-            <a:ext cx="8229600" cy="365760"/>
-          </a:xfrm>
-          <a:prstGeom prst="rect">
-            <a:avLst/>
-          </a:prstGeom>
-          <a:noFill/>
-          <a:ln/>
-        </p:spPr>
-        <p:txBody>
-          <a:bodyPr wrap="square" lIns="0" tIns="0" rIns="0" bIns="0" rtlCol="0" anchor="ctr"/>
-          <a:lstStyle/>
-          <a:p>
-            <a:pPr indent="0" marL="0">
-              <a:buNone/>
-            </a:pPr>
-            <a:r>
-              <a:rPr lang="en-US" sz="1300" b="1" spc="400" kern="0" dirty="0">
+            <a:off x="548640" y="365760"/>
+            <a:ext cx="8046720" cy="274320"/>
+          </a:xfrm>
+          <a:prstGeom prst="rect">
+            <a:avLst/>
+          </a:prstGeom>
+          <a:noFill/>
+          <a:ln/>
+        </p:spPr>
+        <p:txBody>
+          <a:bodyPr wrap="square" lIns="0" tIns="0" rIns="0" bIns="0" rtlCol="0" anchor="ctr"/>
+          <a:lstStyle/>
+          <a:p>
+            <a:pPr indent="0" marL="0">
+              <a:buNone/>
+            </a:pPr>
+            <a:r>
+              <a:rPr lang="en-US" sz="1100" b="1" spc="300" kern="0" dirty="0">
                 <a:solidFill>
                   <a:srgbClr val="9378FF"/>
                 </a:solidFill>
@@ -7298,9 +9172,9 @@
                 <a:ea typeface="Syne" pitchFamily="34" charset="-122"/>
                 <a:cs typeface="Syne" pitchFamily="34" charset="-120"/>
               </a:rPr>
-              <a:t>LIVE</a:t>
-            </a:r>
-            <a:endParaRPr lang="en-US" sz="1300" dirty="0"/>
+              <a:t>WAR STORY</a:t>
+            </a:r>
+            <a:endParaRPr lang="en-US" sz="1100" dirty="0"/>
           </a:p>
         </p:txBody>
       </p:sp>
@@ -7312,34 +9186,34 @@
         </p:nvSpPr>
         <p:spPr>
           <a:xfrm>
-            <a:off x="548640" y="1737360"/>
-            <a:ext cx="8229600" cy="1280160"/>
-          </a:xfrm>
-          <a:prstGeom prst="rect">
-            <a:avLst/>
-          </a:prstGeom>
-          <a:noFill/>
-          <a:ln/>
-        </p:spPr>
-        <p:txBody>
-          <a:bodyPr wrap="square" lIns="0" tIns="0" rIns="0" bIns="0" rtlCol="0" anchor="ctr"/>
-          <a:lstStyle/>
-          <a:p>
-            <a:pPr indent="0" marL="0">
-              <a:buNone/>
-            </a:pPr>
-            <a:r>
-              <a:rPr lang="en-US" sz="3400" b="1" dirty="0">
-                <a:solidFill>
-                  <a:srgbClr val="FFFFFF"/>
+            <a:off x="548640" y="658368"/>
+            <a:ext cx="8046720" cy="457200"/>
+          </a:xfrm>
+          <a:prstGeom prst="rect">
+            <a:avLst/>
+          </a:prstGeom>
+          <a:noFill/>
+          <a:ln/>
+        </p:spPr>
+        <p:txBody>
+          <a:bodyPr wrap="square" lIns="0" tIns="0" rIns="0" bIns="0" rtlCol="0" anchor="ctr"/>
+          <a:lstStyle/>
+          <a:p>
+            <a:pPr indent="0" marL="0">
+              <a:buNone/>
+            </a:pPr>
+            <a:r>
+              <a:rPr lang="en-US" sz="2400" b="1" dirty="0">
+                <a:solidFill>
+                  <a:srgbClr val="2E2C32"/>
                 </a:solidFill>
                 <a:latin typeface="Syne" pitchFamily="34" charset="0"/>
                 <a:ea typeface="Syne" pitchFamily="34" charset="-122"/>
                 <a:cs typeface="Syne" pitchFamily="34" charset="-120"/>
               </a:rPr>
-              <a:t>Watch it grow, COMPACT, snap back, keep going.</a:t>
-            </a:r>
-            <a:endParaRPr lang="en-US" sz="3400" dirty="0"/>
+              <a:t>The agent that froze at 0% CPU</a:t>
+            </a:r>
+            <a:endParaRPr lang="en-US" sz="2400" dirty="0"/>
           </a:p>
         </p:txBody>
       </p:sp>
@@ -7351,34 +9225,34 @@
         </p:nvSpPr>
         <p:spPr>
           <a:xfrm>
-            <a:off x="548640" y="3200400"/>
-            <a:ext cx="8229600" cy="365760"/>
-          </a:xfrm>
-          <a:prstGeom prst="rect">
-            <a:avLst/>
-          </a:prstGeom>
-          <a:noFill/>
-          <a:ln/>
-        </p:spPr>
-        <p:txBody>
-          <a:bodyPr wrap="square" lIns="0" tIns="0" rIns="0" bIns="0" rtlCol="0" anchor="ctr"/>
-          <a:lstStyle/>
-          <a:p>
-            <a:pPr indent="0" marL="0">
-              <a:buNone/>
-            </a:pPr>
-            <a:r>
-              <a:rPr lang="en-US" sz="1500" dirty="0">
+            <a:off x="548640" y="1463040"/>
+            <a:ext cx="8046720" cy="914400"/>
+          </a:xfrm>
+          <a:prstGeom prst="rect">
+            <a:avLst/>
+          </a:prstGeom>
+          <a:noFill/>
+          <a:ln/>
+        </p:spPr>
+        <p:txBody>
+          <a:bodyPr wrap="square" lIns="0" tIns="0" rIns="0" bIns="0" rtlCol="0" anchor="ctr"/>
+          <a:lstStyle/>
+          <a:p>
+            <a:pPr indent="0" marL="0">
+              <a:buNone/>
+            </a:pPr>
+            <a:r>
+              <a:rPr lang="en-US" sz="4000" b="1" dirty="0">
                 <a:solidFill>
                   <a:srgbClr val="9378FF"/>
                 </a:solidFill>
-                <a:latin typeface="Courier New" pitchFamily="34" charset="0"/>
-                <a:ea typeface="Courier New" pitchFamily="34" charset="-122"/>
-                <a:cs typeface="Courier New" pitchFamily="34" charset="-120"/>
-              </a:rPr>
-              <a:t>python run.py     ·     cat run/notes.md</a:t>
-            </a:r>
-            <a:endParaRPr lang="en-US" sz="1500" dirty="0"/>
+                <a:latin typeface="Syne" pitchFamily="34" charset="0"/>
+                <a:ea typeface="Syne" pitchFamily="34" charset="-122"/>
+                <a:cs typeface="Syne" pitchFamily="34" charset="-120"/>
+              </a:rPr>
+              <a:t>no error. just gone.</a:t>
+            </a:r>
+            <a:endParaRPr lang="en-US" sz="4000" dirty="0"/>
           </a:p>
         </p:txBody>
       </p:sp>
@@ -7390,32 +9264,105 @@
         </p:nvSpPr>
         <p:spPr>
           <a:xfrm>
-            <a:off x="548640" y="3749040"/>
-            <a:ext cx="8229600" cy="365760"/>
-          </a:xfrm>
-          <a:prstGeom prst="rect">
-            <a:avLst/>
-          </a:prstGeom>
-          <a:noFill/>
-          <a:ln/>
-        </p:spPr>
-        <p:txBody>
-          <a:bodyPr wrap="square" lIns="0" tIns="0" rIns="0" bIns="0" rtlCol="0" anchor="ctr"/>
-          <a:lstStyle/>
-          <a:p>
-            <a:pPr indent="0" marL="0">
-              <a:buNone/>
-            </a:pPr>
-            <a:r>
-              <a:rPr lang="en-US" sz="1400" dirty="0">
-                <a:solidFill>
-                  <a:srgbClr val="CADCFC"/>
+            <a:off x="548640" y="2606040"/>
+            <a:ext cx="8046720" cy="1097280"/>
+          </a:xfrm>
+          <a:prstGeom prst="rect">
+            <a:avLst/>
+          </a:prstGeom>
+          <a:noFill/>
+          <a:ln/>
+        </p:spPr>
+        <p:txBody>
+          <a:bodyPr wrap="square" lIns="0" tIns="0" rIns="0" bIns="0" rtlCol="0" anchor="ctr"/>
+          <a:lstStyle/>
+          <a:p>
+            <a:pPr indent="0" marL="0">
+              <a:buNone/>
+            </a:pPr>
+            <a:r>
+              <a:rPr lang="en-US" sz="1600" dirty="0">
+                <a:solidFill>
+                  <a:srgbClr val="2E2C32"/>
                 </a:solidFill>
                 <a:latin typeface="Manrope" pitchFamily="34" charset="0"/>
                 <a:ea typeface="Manrope" pitchFamily="34" charset="-122"/>
                 <a:cs typeface="Manrope" pitchFamily="34" charset="-120"/>
               </a:rPr>
-              <a:t>Offline. No key. The window forgets; the scratchpad does not.</a:t>
+              <a:t>Runs hung forever, Python idle, past the library timeout. Fix: a hard wall-clock watchdog on a worker thread (nim.py).</a:t>
+            </a:r>
+            <a:endParaRPr lang="en-US" sz="1600" dirty="0"/>
+          </a:p>
+        </p:txBody>
+      </p:sp>
+      <p:sp>
+        <p:nvSpPr>
+          <p:cNvPr id="6" name="Shape 4"/>
+          <p:cNvSpPr/>
+          <p:nvPr/>
+        </p:nvSpPr>
+        <p:spPr>
+          <a:xfrm>
+            <a:off x="548640" y="3886200"/>
+            <a:ext cx="91440" cy="457200"/>
+          </a:xfrm>
+          <a:prstGeom prst="rect">
+            <a:avLst/>
+          </a:prstGeom>
+          <a:solidFill>
+            <a:srgbClr val="9378FF"/>
+          </a:solidFill>
+          <a:ln/>
+        </p:spPr>
+      </p:sp>
+      <p:sp>
+        <p:nvSpPr>
+          <p:cNvPr id="7" name="Text 5"/>
+          <p:cNvSpPr/>
+          <p:nvPr/>
+        </p:nvSpPr>
+        <p:spPr>
+          <a:xfrm>
+            <a:off x="768096" y="3886200"/>
+            <a:ext cx="7863840" cy="457200"/>
+          </a:xfrm>
+          <a:prstGeom prst="rect">
+            <a:avLst/>
+          </a:prstGeom>
+          <a:noFill/>
+          <a:ln/>
+        </p:spPr>
+        <p:txBody>
+          <a:bodyPr wrap="square" lIns="0" tIns="0" rIns="0" bIns="0" rtlCol="0" anchor="ctr"/>
+          <a:lstStyle/>
+          <a:p>
+            <a:pPr indent="0" marL="0">
+              <a:buNone/>
+            </a:pPr>
+            <a:r>
+              <a:rPr lang="en-US" sz="1400" b="1" dirty="0">
+                <a:solidFill>
+                  <a:srgbClr val="7B5EF0"/>
+                </a:solidFill>
+                <a:latin typeface="Manrope" pitchFamily="34" charset="0"/>
+                <a:ea typeface="Manrope" pitchFamily="34" charset="-122"/>
+                <a:cs typeface="Manrope" pitchFamily="34" charset="-120"/>
+              </a:rPr>
+              <a:t>Lesson  </a:t>
+            </a:r>
+            <a:pPr indent="0" marL="0">
+              <a:buNone/>
+            </a:pPr>
+            <a:r>
+              <a:rPr lang="en-US" sz="1400" dirty="0">
+                <a:solidFill>
+                  <a:srgbClr val="655E74"/>
+                </a:solidFill>
+                <a:latin typeface="Manrope" pitchFamily="34" charset="0"/>
+                <a:ea typeface="Manrope" pitchFamily="34" charset="-122"/>
+                <a:cs typeface="Manrope" pitchFamily="34" charset="-120"/>
+              </a:rPr>
+              <a:t>Do not trust a library's timeout.</a:t>
             </a:r>
             <a:endParaRPr lang="en-US" sz="1400" dirty="0"/>
           </a:p>
@@ -7423,7 +9370,7 @@
       </p:sp>
       <p:pic>
         <p:nvPicPr>
-          <p:cNvPr id="6" name="Image 0" descr="preencoded.png">    </p:cNvPr>
+          <p:cNvPr id="8" name="Image 0" descr="preencoded.png">    </p:cNvPr>
           <p:cNvPicPr>
             <a:picLocks noChangeAspect="1"/>
           </p:cNvPicPr>
@@ -7447,7 +9394,7 @@
       </p:pic>
       <p:sp>
         <p:nvSpPr>
-          <p:cNvPr id="7" name="Text 4"/>
+          <p:cNvPr id="9" name="Text 6"/>
           <p:cNvSpPr/>
           <p:nvPr/>
         </p:nvSpPr>
@@ -7472,7 +9419,7 @@
             <a:r>
               <a:rPr lang="en-US" sz="1100" b="1" dirty="0">
                 <a:solidFill>
-                  <a:srgbClr val="FFFFFF"/>
+                  <a:srgbClr val="2E2C32"/>
                 </a:solidFill>
                 <a:latin typeface="Syne" pitchFamily="34" charset="0"/>
                 <a:ea typeface="Syne" pitchFamily="34" charset="-122"/>
@@ -7500,7 +9447,7 @@
       </p:sp>
       <p:sp>
         <p:nvSpPr>
-          <p:cNvPr id="8" name="Text 5"/>
+          <p:cNvPr id="10" name="Text 7"/>
           <p:cNvSpPr/>
           <p:nvPr/>
         </p:nvSpPr>

</xml_diff>